<commit_message>
Add appendix slide on upstream source filters (zero total debt, blank capex); renumber appendix
Co-Authored-By: Claude Sonnet 5.5 <noreply@anthropic.com>
Claude-Session: https://claude.ai/code/session_017of5yU3bfrpCMXsVcsfLUs
</commit_message>
<xml_diff>
--- a/out/Biotech_MVE_vs_Age.pptx
+++ b/out/Biotech_MVE_vs_Age.pptx
@@ -14,9 +14,10 @@
     <p:sldId id="262" r:id="rId8"/>
     <p:sldId id="263" r:id="rId9"/>
     <p:sldId id="264" r:id="rId10"/>
+    <p:sldId id="265" r:id="rId11"/>
   </p:sldIdLst>
   <p:notesMasterIdLst>
-    <p:notesMasterId r:id="rId11"/>
+    <p:notesMasterId r:id="rId12"/>
   </p:notesMasterIdLst>
   <p:sldSz cx="12192000" cy="6858000"/>
   <p:notesSz cx="6858000" cy="12192000"/>
@@ -115,7 +116,7 @@
   <p:extLst>
     <p:ext uri="{521415D9-36F7-43E2-AB2F-B90AF26B5E84}">
       <p14:sectionLst xmlns:p14="http://schemas.microsoft.com/office/powerpoint/2010/main">
-        <p14:section name="Main" id="{cee0cb03-9b84-ef06-9e39-9e59d2962287}">
+        <p14:section name="Main" id="{e20b97fe-dd95-b591-3914-3596a240ca30}">
           <p14:sldIdLst>
             <p14:sldId id="256"/>
             <p14:sldId id="257"/>
@@ -125,11 +126,12 @@
             <p14:sldId id="261"/>
           </p14:sldIdLst>
         </p14:section>
-        <p14:section name="Appendix" id="{b9ccff8c-966b-c3db-b095-0dbde234020b}">
+        <p14:section name="Appendix" id="{e395e33f-dc30-46e0-37ed-2147049329c9}">
           <p14:sldIdLst>
             <p14:sldId id="262"/>
             <p14:sldId id="263"/>
             <p14:sldId id="264"/>
+            <p14:sldId id="265"/>
           </p14:sldIdLst>
         </p14:section>
       </p14:sectionLst>
@@ -916,6 +918,94 @@
 </p:notes>
 </file>
 
+<file path=ppt/notesSlides/notesSlide10.xml><?xml version="1.0" encoding="utf-8"?>
+<p:notes xmlns:a="http://schemas.openxmlformats.org/drawingml/2006/main" xmlns:r="http://schemas.openxmlformats.org/officeDocument/2006/relationships" xmlns:p="http://schemas.openxmlformats.org/presentationml/2006/main">
+  <p:cSld>
+    <p:spTree>
+      <p:nvGrpSpPr>
+        <p:cNvPr id="1" name=""/>
+        <p:cNvGrpSpPr/>
+        <p:nvPr/>
+      </p:nvGrpSpPr>
+      <p:grpSpPr>
+        <a:xfrm>
+          <a:off x="0" y="0"/>
+          <a:ext cx="0" cy="0"/>
+          <a:chOff x="0" y="0"/>
+          <a:chExt cx="0" cy="0"/>
+        </a:xfrm>
+      </p:grpSpPr>
+      <p:sp>
+        <p:nvSpPr>
+          <p:cNvPr id="2" name="Slide Image Placeholder 1"/>
+          <p:cNvSpPr>
+            <a:spLocks noGrp="1" noRot="1" noChangeAspect="1"/>
+          </p:cNvSpPr>
+          <p:nvPr>
+            <p:ph type="sldImg"/>
+          </p:nvPr>
+        </p:nvSpPr>
+        <p:spPr/>
+      </p:sp>
+      <p:sp>
+        <p:nvSpPr>
+          <p:cNvPr id="3" name="Notes Placeholder 2"/>
+          <p:cNvSpPr>
+            <a:spLocks noGrp="1"/>
+          </p:cNvSpPr>
+          <p:nvPr>
+            <p:ph type="body" idx="1"/>
+          </p:nvPr>
+        </p:nvSpPr>
+        <p:spPr/>
+        <p:txBody>
+          <a:bodyPr/>
+          <a:lstStyle/>
+          <a:p>
+            <a:r>
+              <a:rPr lang="en-US" dirty="0"/>
+              <a:t>Summary statistics are for the final sample. The mean MVE is far above the median because of a few very large firms.</a:t>
+            </a:r>
+            <a:endParaRPr lang="en-US" dirty="0"/>
+          </a:p>
+        </p:txBody>
+      </p:sp>
+      <p:sp>
+        <p:nvSpPr>
+          <p:cNvPr id="4" name="Slide Number Placeholder 3"/>
+          <p:cNvSpPr>
+            <a:spLocks noGrp="1"/>
+          </p:cNvSpPr>
+          <p:nvPr>
+            <p:ph type="sldNum" sz="quarter" idx="10"/>
+          </p:nvPr>
+        </p:nvSpPr>
+        <p:spPr/>
+        <p:txBody>
+          <a:bodyPr/>
+          <a:lstStyle/>
+          <a:p>
+            <a:fld id="{F7021451-1387-4CA6-816F-3879F97B5CBC}" type="slidenum">
+              <a:rPr lang="en-US"/>
+              <a:t>10</a:t>
+            </a:fld>
+            <a:endParaRPr lang="en-US"/>
+          </a:p>
+        </p:txBody>
+      </p:sp>
+    </p:spTree>
+    <p:extLst>
+      <p:ext uri="{BB962C8B-B14F-4D97-AF65-F5344CB8AC3E}">
+        <p14:creationId xmlns:p14="http://schemas.microsoft.com/office/powerpoint/2010/main" val="1024086991"/>
+      </p:ext>
+    </p:extLst>
+  </p:cSld>
+  <p:clrMapOvr>
+    <a:masterClrMapping/>
+  </p:clrMapOvr>
+</p:notes>
+</file>
+
 <file path=ppt/notesSlides/notesSlide2.xml><?xml version="1.0" encoding="utf-8"?>
 <p:notes xmlns:a="http://schemas.openxmlformats.org/drawingml/2006/main" xmlns:r="http://schemas.openxmlformats.org/officeDocument/2006/relationships" xmlns:p="http://schemas.openxmlformats.org/presentationml/2006/main">
   <p:cSld>
@@ -1050,7 +1140,7 @@
           <a:p>
             <a:r>
               <a:rPr lang="en-US" dirty="0"/>
-              <a:t>Final sample is 833 company-years for 201 firms. The $100M revenue floor was applied in the data file and matters a lot: without it the correlation is much weaker (Appendix A1). We deliberately did not winsorize; the appendix shows why.</a:t>
+              <a:t>Final sample is 833 company-years for 201 firms. The $100M revenue floor was applied in the data file and matters a lot: without it the correlation is much weaker (Appendix A2). We deliberately did not winsorize; the appendix shows why.</a:t>
             </a:r>
             <a:endParaRPr lang="en-US" dirty="0"/>
           </a:p>
@@ -1402,7 +1492,7 @@
           <a:p>
             <a:r>
               <a:rPr lang="en-US" dirty="0"/>
-              <a:t>Why winsorizing was not used: it changes Pearson but not the rank-based result or the slope.</a:t>
+              <a:t>The data used here is a simplified extract of a table with over 100,000 lines. Before extraction, rows with zero total debt and rows with blank capex were removed, and the $100M revenue floor was applied. We have not measured how the first two filters affect the result.</a:t>
             </a:r>
             <a:endParaRPr lang="en-US" dirty="0"/>
           </a:p>
@@ -1490,7 +1580,7 @@
           <a:p>
             <a:r>
               <a:rPr lang="en-US" dirty="0"/>
-              <a:t>Within-firm only means each firm's average is removed, so it measures whether a firm's MVE rises as it ages; it is positive but small, and it also reflects calendar time.</a:t>
+              <a:t>Why winsorizing was not used: it changes Pearson but not the rank-based result or the slope.</a:t>
             </a:r>
             <a:endParaRPr lang="en-US" dirty="0"/>
           </a:p>
@@ -1578,7 +1668,7 @@
           <a:p>
             <a:r>
               <a:rPr lang="en-US" dirty="0"/>
-              <a:t>Summary statistics are for the final sample. The mean MVE is far above the median because of a few very large firms.</a:t>
+              <a:t>Within-firm only means each firm's average is removed, so it measures whether a firm's MVE rises as it ages; it is positive but small, and it also reflects calendar time.</a:t>
             </a:r>
             <a:endParaRPr lang="en-US" dirty="0"/>
           </a:p>
@@ -2625,6 +2715,1544 @@
 </p:sld>
 </file>
 
+<file path=ppt/slides/slide10.xml><?xml version="1.0" encoding="utf-8"?>
+<p:sld xmlns:a="http://schemas.openxmlformats.org/drawingml/2006/main" xmlns:r="http://schemas.openxmlformats.org/officeDocument/2006/relationships" xmlns:p="http://schemas.openxmlformats.org/presentationml/2006/main">
+  <p:cSld name="Slide 10">
+    <p:spTree>
+      <p:nvGrpSpPr>
+        <p:cNvPr id="1" name=""/>
+        <p:cNvGrpSpPr/>
+        <p:nvPr/>
+      </p:nvGrpSpPr>
+      <p:grpSpPr>
+        <a:xfrm>
+          <a:off x="0" y="0"/>
+          <a:ext cx="0" cy="0"/>
+          <a:chOff x="0" y="0"/>
+          <a:chExt cx="0" cy="0"/>
+        </a:xfrm>
+      </p:grpSpPr>
+      <p:sp>
+        <p:nvSpPr>
+          <p:cNvPr id="2" name="Text 0"/>
+          <p:cNvSpPr/>
+          <p:nvPr>
+            <p:ph idx="100" type="title" hasCustomPrompt="1"/>
+          </p:nvPr>
+        </p:nvSpPr>
+        <p:spPr>
+          <a:xfrm>
+            <a:off x="548640" y="320040"/>
+            <a:ext cx="11091672" cy="914400"/>
+          </a:xfrm>
+          <a:prstGeom prst="rect">
+            <a:avLst/>
+          </a:prstGeom>
+          <a:noFill/>
+          <a:ln/>
+        </p:spPr>
+        <p:txBody>
+          <a:bodyPr wrap="square" lIns="0" tIns="0" rIns="0" bIns="0" rtlCol="0" anchor="ctr"/>
+          <a:lstStyle/>
+          <a:p>
+            <a:pPr algn="l" indent="0" marL="0">
+              <a:buNone/>
+            </a:pPr>
+            <a:r>
+              <a:rPr lang="en-US" sz="3000" b="1" dirty="0">
+                <a:solidFill>
+                  <a:schemeClr val="tx2"/>
+                </a:solidFill>
+                <a:latin typeface="Cambria" pitchFamily="34" charset="0"/>
+                <a:ea typeface="Cambria" pitchFamily="34" charset="-122"/>
+                <a:cs typeface="Cambria" pitchFamily="34" charset="-120"/>
+              </a:rPr>
+              <a:t>Appendix A4: Summary statistics and methods</a:t>
+            </a:r>
+            <a:endParaRPr lang="en-US" sz="3000" dirty="0"/>
+          </a:p>
+        </p:txBody>
+      </p:sp>
+      <p:graphicFrame>
+        <p:nvGraphicFramePr>
+          <p:cNvPr id="11" name="Summary statistics table"/>
+          <p:cNvGraphicFramePr>
+            <a:graphicFrameLocks noGrp="1"/>
+          </p:cNvGraphicFramePr>
+          <p:nvPr>
+            <p:extLst>
+              <p:ext uri="{D42A27DB-BD31-4B8C-83A1-F6EECF244321}">
+                <p14:modId xmlns:p14="http://schemas.microsoft.com/office/powerpoint/2010/main" val="1579011935"/>
+              </p:ext>
+            </p:extLst>
+          </p:nvPr>
+        </p:nvGraphicFramePr>
+        <p:xfrm>
+          <a:off x="548640" y="1371600"/>
+          <a:ext cx="6583680" cy="914400"/>
+        </p:xfrm>
+        <a:graphic>
+          <a:graphicData uri="http://schemas.openxmlformats.org/drawingml/2006/table">
+            <a:tbl>
+              <a:tblPr/>
+              <a:tblGrid>
+                <a:gridCol w="2651760"/>
+                <a:gridCol w="822960"/>
+                <a:gridCol w="1005840"/>
+                <a:gridCol w="1005840"/>
+                <a:gridCol w="1097280"/>
+              </a:tblGrid>
+              <a:tr h="384048">
+                <a:tc>
+                  <a:txBody>
+                    <a:bodyPr/>
+                    <a:lstStyle/>
+                    <a:p>
+                      <a:pPr algn="l" indent="0" marL="0">
+                        <a:buNone/>
+                      </a:pPr>
+                      <a:r>
+                        <a:rPr lang="en-US" sz="1300" b="1" dirty="0">
+                          <a:solidFill>
+                            <a:schemeClr val="bg1"/>
+                          </a:solidFill>
+                        </a:rPr>
+                        <a:t>Variable</a:t>
+                      </a:r>
+                      <a:endParaRPr lang="en-US" sz="1300" dirty="0"/>
+                    </a:p>
+                  </a:txBody>
+                  <a:tcPr marL="91440" marR="91440" marT="45720" marB="45720" anchor="ctr">
+                    <a:lnL w="6350" cap="flat" cmpd="sng" algn="ctr">
+                      <a:solidFill>
+                        <a:srgbClr val="D5DDE0"/>
+                      </a:solidFill>
+                      <a:prstDash val="solid"/>
+                      <a:round/>
+                      <a:headEnd type="none" w="med" len="med"/>
+                      <a:tailEnd type="none" w="med" len="med"/>
+                    </a:lnL>
+                    <a:lnR w="6350" cap="flat" cmpd="sng" algn="ctr">
+                      <a:solidFill>
+                        <a:srgbClr val="D5DDE0"/>
+                      </a:solidFill>
+                      <a:prstDash val="solid"/>
+                      <a:round/>
+                      <a:headEnd type="none" w="med" len="med"/>
+                      <a:tailEnd type="none" w="med" len="med"/>
+                    </a:lnR>
+                    <a:lnT w="6350" cap="flat" cmpd="sng" algn="ctr">
+                      <a:solidFill>
+                        <a:srgbClr val="D5DDE0"/>
+                      </a:solidFill>
+                      <a:prstDash val="solid"/>
+                      <a:round/>
+                      <a:headEnd type="none" w="med" len="med"/>
+                      <a:tailEnd type="none" w="med" len="med"/>
+                    </a:lnT>
+                    <a:lnB w="6350" cap="flat" cmpd="sng" algn="ctr">
+                      <a:solidFill>
+                        <a:srgbClr val="D5DDE0"/>
+                      </a:solidFill>
+                      <a:prstDash val="solid"/>
+                      <a:round/>
+                      <a:headEnd type="none" w="med" len="med"/>
+                      <a:tailEnd type="none" w="med" len="med"/>
+                    </a:lnB>
+                    <a:solidFill>
+                      <a:schemeClr val="tx2"/>
+                    </a:solidFill>
+                  </a:tcPr>
+                </a:tc>
+                <a:tc>
+                  <a:txBody>
+                    <a:bodyPr/>
+                    <a:lstStyle/>
+                    <a:p>
+                      <a:pPr algn="r" indent="0" marL="0">
+                        <a:buNone/>
+                      </a:pPr>
+                      <a:r>
+                        <a:rPr lang="en-US" sz="1300" b="1" dirty="0">
+                          <a:solidFill>
+                            <a:schemeClr val="bg1"/>
+                          </a:solidFill>
+                        </a:rPr>
+                        <a:t>Min</a:t>
+                      </a:r>
+                      <a:endParaRPr lang="en-US" sz="1300" dirty="0"/>
+                    </a:p>
+                  </a:txBody>
+                  <a:tcPr marL="91440" marR="91440" marT="45720" marB="45720" anchor="ctr">
+                    <a:lnL w="6350" cap="flat" cmpd="sng" algn="ctr">
+                      <a:solidFill>
+                        <a:srgbClr val="D5DDE0"/>
+                      </a:solidFill>
+                      <a:prstDash val="solid"/>
+                      <a:round/>
+                      <a:headEnd type="none" w="med" len="med"/>
+                      <a:tailEnd type="none" w="med" len="med"/>
+                    </a:lnL>
+                    <a:lnR w="6350" cap="flat" cmpd="sng" algn="ctr">
+                      <a:solidFill>
+                        <a:srgbClr val="D5DDE0"/>
+                      </a:solidFill>
+                      <a:prstDash val="solid"/>
+                      <a:round/>
+                      <a:headEnd type="none" w="med" len="med"/>
+                      <a:tailEnd type="none" w="med" len="med"/>
+                    </a:lnR>
+                    <a:lnT w="6350" cap="flat" cmpd="sng" algn="ctr">
+                      <a:solidFill>
+                        <a:srgbClr val="D5DDE0"/>
+                      </a:solidFill>
+                      <a:prstDash val="solid"/>
+                      <a:round/>
+                      <a:headEnd type="none" w="med" len="med"/>
+                      <a:tailEnd type="none" w="med" len="med"/>
+                    </a:lnT>
+                    <a:lnB w="6350" cap="flat" cmpd="sng" algn="ctr">
+                      <a:solidFill>
+                        <a:srgbClr val="D5DDE0"/>
+                      </a:solidFill>
+                      <a:prstDash val="solid"/>
+                      <a:round/>
+                      <a:headEnd type="none" w="med" len="med"/>
+                      <a:tailEnd type="none" w="med" len="med"/>
+                    </a:lnB>
+                    <a:solidFill>
+                      <a:schemeClr val="tx2"/>
+                    </a:solidFill>
+                  </a:tcPr>
+                </a:tc>
+                <a:tc>
+                  <a:txBody>
+                    <a:bodyPr/>
+                    <a:lstStyle/>
+                    <a:p>
+                      <a:pPr algn="r" indent="0" marL="0">
+                        <a:buNone/>
+                      </a:pPr>
+                      <a:r>
+                        <a:rPr lang="en-US" sz="1300" b="1" dirty="0">
+                          <a:solidFill>
+                            <a:schemeClr val="bg1"/>
+                          </a:solidFill>
+                        </a:rPr>
+                        <a:t>Median</a:t>
+                      </a:r>
+                      <a:endParaRPr lang="en-US" sz="1300" dirty="0"/>
+                    </a:p>
+                  </a:txBody>
+                  <a:tcPr marL="91440" marR="91440" marT="45720" marB="45720" anchor="ctr">
+                    <a:lnL w="6350" cap="flat" cmpd="sng" algn="ctr">
+                      <a:solidFill>
+                        <a:srgbClr val="D5DDE0"/>
+                      </a:solidFill>
+                      <a:prstDash val="solid"/>
+                      <a:round/>
+                      <a:headEnd type="none" w="med" len="med"/>
+                      <a:tailEnd type="none" w="med" len="med"/>
+                    </a:lnL>
+                    <a:lnR w="6350" cap="flat" cmpd="sng" algn="ctr">
+                      <a:solidFill>
+                        <a:srgbClr val="D5DDE0"/>
+                      </a:solidFill>
+                      <a:prstDash val="solid"/>
+                      <a:round/>
+                      <a:headEnd type="none" w="med" len="med"/>
+                      <a:tailEnd type="none" w="med" len="med"/>
+                    </a:lnR>
+                    <a:lnT w="6350" cap="flat" cmpd="sng" algn="ctr">
+                      <a:solidFill>
+                        <a:srgbClr val="D5DDE0"/>
+                      </a:solidFill>
+                      <a:prstDash val="solid"/>
+                      <a:round/>
+                      <a:headEnd type="none" w="med" len="med"/>
+                      <a:tailEnd type="none" w="med" len="med"/>
+                    </a:lnT>
+                    <a:lnB w="6350" cap="flat" cmpd="sng" algn="ctr">
+                      <a:solidFill>
+                        <a:srgbClr val="D5DDE0"/>
+                      </a:solidFill>
+                      <a:prstDash val="solid"/>
+                      <a:round/>
+                      <a:headEnd type="none" w="med" len="med"/>
+                      <a:tailEnd type="none" w="med" len="med"/>
+                    </a:lnB>
+                    <a:solidFill>
+                      <a:schemeClr val="tx2"/>
+                    </a:solidFill>
+                  </a:tcPr>
+                </a:tc>
+                <a:tc>
+                  <a:txBody>
+                    <a:bodyPr/>
+                    <a:lstStyle/>
+                    <a:p>
+                      <a:pPr algn="r" indent="0" marL="0">
+                        <a:buNone/>
+                      </a:pPr>
+                      <a:r>
+                        <a:rPr lang="en-US" sz="1300" b="1" dirty="0">
+                          <a:solidFill>
+                            <a:schemeClr val="bg1"/>
+                          </a:solidFill>
+                        </a:rPr>
+                        <a:t>Mean</a:t>
+                      </a:r>
+                      <a:endParaRPr lang="en-US" sz="1300" dirty="0"/>
+                    </a:p>
+                  </a:txBody>
+                  <a:tcPr marL="91440" marR="91440" marT="45720" marB="45720" anchor="ctr">
+                    <a:lnL w="6350" cap="flat" cmpd="sng" algn="ctr">
+                      <a:solidFill>
+                        <a:srgbClr val="D5DDE0"/>
+                      </a:solidFill>
+                      <a:prstDash val="solid"/>
+                      <a:round/>
+                      <a:headEnd type="none" w="med" len="med"/>
+                      <a:tailEnd type="none" w="med" len="med"/>
+                    </a:lnL>
+                    <a:lnR w="6350" cap="flat" cmpd="sng" algn="ctr">
+                      <a:solidFill>
+                        <a:srgbClr val="D5DDE0"/>
+                      </a:solidFill>
+                      <a:prstDash val="solid"/>
+                      <a:round/>
+                      <a:headEnd type="none" w="med" len="med"/>
+                      <a:tailEnd type="none" w="med" len="med"/>
+                    </a:lnR>
+                    <a:lnT w="6350" cap="flat" cmpd="sng" algn="ctr">
+                      <a:solidFill>
+                        <a:srgbClr val="D5DDE0"/>
+                      </a:solidFill>
+                      <a:prstDash val="solid"/>
+                      <a:round/>
+                      <a:headEnd type="none" w="med" len="med"/>
+                      <a:tailEnd type="none" w="med" len="med"/>
+                    </a:lnT>
+                    <a:lnB w="6350" cap="flat" cmpd="sng" algn="ctr">
+                      <a:solidFill>
+                        <a:srgbClr val="D5DDE0"/>
+                      </a:solidFill>
+                      <a:prstDash val="solid"/>
+                      <a:round/>
+                      <a:headEnd type="none" w="med" len="med"/>
+                      <a:tailEnd type="none" w="med" len="med"/>
+                    </a:lnB>
+                    <a:solidFill>
+                      <a:schemeClr val="tx2"/>
+                    </a:solidFill>
+                  </a:tcPr>
+                </a:tc>
+                <a:tc>
+                  <a:txBody>
+                    <a:bodyPr/>
+                    <a:lstStyle/>
+                    <a:p>
+                      <a:pPr algn="r" indent="0" marL="0">
+                        <a:buNone/>
+                      </a:pPr>
+                      <a:r>
+                        <a:rPr lang="en-US" sz="1300" b="1" dirty="0">
+                          <a:solidFill>
+                            <a:schemeClr val="bg1"/>
+                          </a:solidFill>
+                        </a:rPr>
+                        <a:t>Max</a:t>
+                      </a:r>
+                      <a:endParaRPr lang="en-US" sz="1300" dirty="0"/>
+                    </a:p>
+                  </a:txBody>
+                  <a:tcPr marL="91440" marR="91440" marT="45720" marB="45720" anchor="ctr">
+                    <a:lnL w="6350" cap="flat" cmpd="sng" algn="ctr">
+                      <a:solidFill>
+                        <a:srgbClr val="D5DDE0"/>
+                      </a:solidFill>
+                      <a:prstDash val="solid"/>
+                      <a:round/>
+                      <a:headEnd type="none" w="med" len="med"/>
+                      <a:tailEnd type="none" w="med" len="med"/>
+                    </a:lnL>
+                    <a:lnR w="6350" cap="flat" cmpd="sng" algn="ctr">
+                      <a:solidFill>
+                        <a:srgbClr val="D5DDE0"/>
+                      </a:solidFill>
+                      <a:prstDash val="solid"/>
+                      <a:round/>
+                      <a:headEnd type="none" w="med" len="med"/>
+                      <a:tailEnd type="none" w="med" len="med"/>
+                    </a:lnR>
+                    <a:lnT w="6350" cap="flat" cmpd="sng" algn="ctr">
+                      <a:solidFill>
+                        <a:srgbClr val="D5DDE0"/>
+                      </a:solidFill>
+                      <a:prstDash val="solid"/>
+                      <a:round/>
+                      <a:headEnd type="none" w="med" len="med"/>
+                      <a:tailEnd type="none" w="med" len="med"/>
+                    </a:lnT>
+                    <a:lnB w="6350" cap="flat" cmpd="sng" algn="ctr">
+                      <a:solidFill>
+                        <a:srgbClr val="D5DDE0"/>
+                      </a:solidFill>
+                      <a:prstDash val="solid"/>
+                      <a:round/>
+                      <a:headEnd type="none" w="med" len="med"/>
+                      <a:tailEnd type="none" w="med" len="med"/>
+                    </a:lnB>
+                    <a:solidFill>
+                      <a:schemeClr val="tx2"/>
+                    </a:solidFill>
+                  </a:tcPr>
+                </a:tc>
+              </a:tr>
+              <a:tr h="384048">
+                <a:tc>
+                  <a:txBody>
+                    <a:bodyPr/>
+                    <a:lstStyle/>
+                    <a:p>
+                      <a:pPr indent="0" marL="0">
+                        <a:buNone/>
+                      </a:pPr>
+                      <a:r>
+                        <a:rPr lang="en-US" sz="1300" dirty="0">
+                          <a:solidFill>
+                            <a:schemeClr val="tx1"/>
+                          </a:solidFill>
+                        </a:rPr>
+                        <a:t>MVE ($ millions)</a:t>
+                      </a:r>
+                      <a:endParaRPr lang="en-US" sz="1300" dirty="0"/>
+                    </a:p>
+                  </a:txBody>
+                  <a:tcPr marL="91440" marR="91440" marT="45720" marB="45720" anchor="ctr">
+                    <a:lnL w="6350" cap="flat" cmpd="sng" algn="ctr">
+                      <a:solidFill>
+                        <a:srgbClr val="D5DDE0"/>
+                      </a:solidFill>
+                      <a:prstDash val="solid"/>
+                      <a:round/>
+                      <a:headEnd type="none" w="med" len="med"/>
+                      <a:tailEnd type="none" w="med" len="med"/>
+                    </a:lnL>
+                    <a:lnR w="6350" cap="flat" cmpd="sng" algn="ctr">
+                      <a:solidFill>
+                        <a:srgbClr val="D5DDE0"/>
+                      </a:solidFill>
+                      <a:prstDash val="solid"/>
+                      <a:round/>
+                      <a:headEnd type="none" w="med" len="med"/>
+                      <a:tailEnd type="none" w="med" len="med"/>
+                    </a:lnR>
+                    <a:lnT w="6350" cap="flat" cmpd="sng" algn="ctr">
+                      <a:solidFill>
+                        <a:srgbClr val="D5DDE0"/>
+                      </a:solidFill>
+                      <a:prstDash val="solid"/>
+                      <a:round/>
+                      <a:headEnd type="none" w="med" len="med"/>
+                      <a:tailEnd type="none" w="med" len="med"/>
+                    </a:lnT>
+                    <a:lnB w="6350" cap="flat" cmpd="sng" algn="ctr">
+                      <a:solidFill>
+                        <a:srgbClr val="D5DDE0"/>
+                      </a:solidFill>
+                      <a:prstDash val="solid"/>
+                      <a:round/>
+                      <a:headEnd type="none" w="med" len="med"/>
+                      <a:tailEnd type="none" w="med" len="med"/>
+                    </a:lnB>
+                    <a:solidFill>
+                      <a:srgbClr val="FFFFFF"/>
+                    </a:solidFill>
+                  </a:tcPr>
+                </a:tc>
+                <a:tc>
+                  <a:txBody>
+                    <a:bodyPr/>
+                    <a:lstStyle/>
+                    <a:p>
+                      <a:pPr algn="r" indent="0" marL="0">
+                        <a:buNone/>
+                      </a:pPr>
+                      <a:r>
+                        <a:rPr lang="en-US" sz="1300" dirty="0">
+                          <a:solidFill>
+                            <a:schemeClr val="tx1"/>
+                          </a:solidFill>
+                        </a:rPr>
+                        <a:t>16</a:t>
+                      </a:r>
+                      <a:endParaRPr lang="en-US" sz="1300" dirty="0"/>
+                    </a:p>
+                  </a:txBody>
+                  <a:tcPr marL="91440" marR="91440" marT="45720" marB="45720" anchor="ctr">
+                    <a:lnL w="6350" cap="flat" cmpd="sng" algn="ctr">
+                      <a:solidFill>
+                        <a:srgbClr val="D5DDE0"/>
+                      </a:solidFill>
+                      <a:prstDash val="solid"/>
+                      <a:round/>
+                      <a:headEnd type="none" w="med" len="med"/>
+                      <a:tailEnd type="none" w="med" len="med"/>
+                    </a:lnL>
+                    <a:lnR w="6350" cap="flat" cmpd="sng" algn="ctr">
+                      <a:solidFill>
+                        <a:srgbClr val="D5DDE0"/>
+                      </a:solidFill>
+                      <a:prstDash val="solid"/>
+                      <a:round/>
+                      <a:headEnd type="none" w="med" len="med"/>
+                      <a:tailEnd type="none" w="med" len="med"/>
+                    </a:lnR>
+                    <a:lnT w="6350" cap="flat" cmpd="sng" algn="ctr">
+                      <a:solidFill>
+                        <a:srgbClr val="D5DDE0"/>
+                      </a:solidFill>
+                      <a:prstDash val="solid"/>
+                      <a:round/>
+                      <a:headEnd type="none" w="med" len="med"/>
+                      <a:tailEnd type="none" w="med" len="med"/>
+                    </a:lnT>
+                    <a:lnB w="6350" cap="flat" cmpd="sng" algn="ctr">
+                      <a:solidFill>
+                        <a:srgbClr val="D5DDE0"/>
+                      </a:solidFill>
+                      <a:prstDash val="solid"/>
+                      <a:round/>
+                      <a:headEnd type="none" w="med" len="med"/>
+                      <a:tailEnd type="none" w="med" len="med"/>
+                    </a:lnB>
+                    <a:solidFill>
+                      <a:srgbClr val="FFFFFF"/>
+                    </a:solidFill>
+                  </a:tcPr>
+                </a:tc>
+                <a:tc>
+                  <a:txBody>
+                    <a:bodyPr/>
+                    <a:lstStyle/>
+                    <a:p>
+                      <a:pPr algn="r" indent="0" marL="0">
+                        <a:buNone/>
+                      </a:pPr>
+                      <a:r>
+                        <a:rPr lang="en-US" sz="1300" dirty="0">
+                          <a:solidFill>
+                            <a:schemeClr val="tx1"/>
+                          </a:solidFill>
+                        </a:rPr>
+                        <a:t>2,560</a:t>
+                      </a:r>
+                      <a:endParaRPr lang="en-US" sz="1300" dirty="0"/>
+                    </a:p>
+                  </a:txBody>
+                  <a:tcPr marL="91440" marR="91440" marT="45720" marB="45720" anchor="ctr">
+                    <a:lnL w="6350" cap="flat" cmpd="sng" algn="ctr">
+                      <a:solidFill>
+                        <a:srgbClr val="D5DDE0"/>
+                      </a:solidFill>
+                      <a:prstDash val="solid"/>
+                      <a:round/>
+                      <a:headEnd type="none" w="med" len="med"/>
+                      <a:tailEnd type="none" w="med" len="med"/>
+                    </a:lnL>
+                    <a:lnR w="6350" cap="flat" cmpd="sng" algn="ctr">
+                      <a:solidFill>
+                        <a:srgbClr val="D5DDE0"/>
+                      </a:solidFill>
+                      <a:prstDash val="solid"/>
+                      <a:round/>
+                      <a:headEnd type="none" w="med" len="med"/>
+                      <a:tailEnd type="none" w="med" len="med"/>
+                    </a:lnR>
+                    <a:lnT w="6350" cap="flat" cmpd="sng" algn="ctr">
+                      <a:solidFill>
+                        <a:srgbClr val="D5DDE0"/>
+                      </a:solidFill>
+                      <a:prstDash val="solid"/>
+                      <a:round/>
+                      <a:headEnd type="none" w="med" len="med"/>
+                      <a:tailEnd type="none" w="med" len="med"/>
+                    </a:lnT>
+                    <a:lnB w="6350" cap="flat" cmpd="sng" algn="ctr">
+                      <a:solidFill>
+                        <a:srgbClr val="D5DDE0"/>
+                      </a:solidFill>
+                      <a:prstDash val="solid"/>
+                      <a:round/>
+                      <a:headEnd type="none" w="med" len="med"/>
+                      <a:tailEnd type="none" w="med" len="med"/>
+                    </a:lnB>
+                    <a:solidFill>
+                      <a:srgbClr val="FFFFFF"/>
+                    </a:solidFill>
+                  </a:tcPr>
+                </a:tc>
+                <a:tc>
+                  <a:txBody>
+                    <a:bodyPr/>
+                    <a:lstStyle/>
+                    <a:p>
+                      <a:pPr algn="r" indent="0" marL="0">
+                        <a:buNone/>
+                      </a:pPr>
+                      <a:r>
+                        <a:rPr lang="en-US" sz="1300" dirty="0">
+                          <a:solidFill>
+                            <a:schemeClr val="tx1"/>
+                          </a:solidFill>
+                        </a:rPr>
+                        <a:t>13,583</a:t>
+                      </a:r>
+                      <a:endParaRPr lang="en-US" sz="1300" dirty="0"/>
+                    </a:p>
+                  </a:txBody>
+                  <a:tcPr marL="91440" marR="91440" marT="45720" marB="45720" anchor="ctr">
+                    <a:lnL w="6350" cap="flat" cmpd="sng" algn="ctr">
+                      <a:solidFill>
+                        <a:srgbClr val="D5DDE0"/>
+                      </a:solidFill>
+                      <a:prstDash val="solid"/>
+                      <a:round/>
+                      <a:headEnd type="none" w="med" len="med"/>
+                      <a:tailEnd type="none" w="med" len="med"/>
+                    </a:lnL>
+                    <a:lnR w="6350" cap="flat" cmpd="sng" algn="ctr">
+                      <a:solidFill>
+                        <a:srgbClr val="D5DDE0"/>
+                      </a:solidFill>
+                      <a:prstDash val="solid"/>
+                      <a:round/>
+                      <a:headEnd type="none" w="med" len="med"/>
+                      <a:tailEnd type="none" w="med" len="med"/>
+                    </a:lnR>
+                    <a:lnT w="6350" cap="flat" cmpd="sng" algn="ctr">
+                      <a:solidFill>
+                        <a:srgbClr val="D5DDE0"/>
+                      </a:solidFill>
+                      <a:prstDash val="solid"/>
+                      <a:round/>
+                      <a:headEnd type="none" w="med" len="med"/>
+                      <a:tailEnd type="none" w="med" len="med"/>
+                    </a:lnT>
+                    <a:lnB w="6350" cap="flat" cmpd="sng" algn="ctr">
+                      <a:solidFill>
+                        <a:srgbClr val="D5DDE0"/>
+                      </a:solidFill>
+                      <a:prstDash val="solid"/>
+                      <a:round/>
+                      <a:headEnd type="none" w="med" len="med"/>
+                      <a:tailEnd type="none" w="med" len="med"/>
+                    </a:lnB>
+                    <a:solidFill>
+                      <a:srgbClr val="FFFFFF"/>
+                    </a:solidFill>
+                  </a:tcPr>
+                </a:tc>
+                <a:tc>
+                  <a:txBody>
+                    <a:bodyPr/>
+                    <a:lstStyle/>
+                    <a:p>
+                      <a:pPr algn="r" indent="0" marL="0">
+                        <a:buNone/>
+                      </a:pPr>
+                      <a:r>
+                        <a:rPr lang="en-US" sz="1300" dirty="0">
+                          <a:solidFill>
+                            <a:schemeClr val="tx1"/>
+                          </a:solidFill>
+                        </a:rPr>
+                        <a:t>313,686</a:t>
+                      </a:r>
+                      <a:endParaRPr lang="en-US" sz="1300" dirty="0"/>
+                    </a:p>
+                  </a:txBody>
+                  <a:tcPr marL="91440" marR="91440" marT="45720" marB="45720" anchor="ctr">
+                    <a:lnL w="6350" cap="flat" cmpd="sng" algn="ctr">
+                      <a:solidFill>
+                        <a:srgbClr val="D5DDE0"/>
+                      </a:solidFill>
+                      <a:prstDash val="solid"/>
+                      <a:round/>
+                      <a:headEnd type="none" w="med" len="med"/>
+                      <a:tailEnd type="none" w="med" len="med"/>
+                    </a:lnL>
+                    <a:lnR w="6350" cap="flat" cmpd="sng" algn="ctr">
+                      <a:solidFill>
+                        <a:srgbClr val="D5DDE0"/>
+                      </a:solidFill>
+                      <a:prstDash val="solid"/>
+                      <a:round/>
+                      <a:headEnd type="none" w="med" len="med"/>
+                      <a:tailEnd type="none" w="med" len="med"/>
+                    </a:lnR>
+                    <a:lnT w="6350" cap="flat" cmpd="sng" algn="ctr">
+                      <a:solidFill>
+                        <a:srgbClr val="D5DDE0"/>
+                      </a:solidFill>
+                      <a:prstDash val="solid"/>
+                      <a:round/>
+                      <a:headEnd type="none" w="med" len="med"/>
+                      <a:tailEnd type="none" w="med" len="med"/>
+                    </a:lnT>
+                    <a:lnB w="6350" cap="flat" cmpd="sng" algn="ctr">
+                      <a:solidFill>
+                        <a:srgbClr val="D5DDE0"/>
+                      </a:solidFill>
+                      <a:prstDash val="solid"/>
+                      <a:round/>
+                      <a:headEnd type="none" w="med" len="med"/>
+                      <a:tailEnd type="none" w="med" len="med"/>
+                    </a:lnB>
+                    <a:solidFill>
+                      <a:srgbClr val="FFFFFF"/>
+                    </a:solidFill>
+                  </a:tcPr>
+                </a:tc>
+              </a:tr>
+              <a:tr h="384048">
+                <a:tc>
+                  <a:txBody>
+                    <a:bodyPr/>
+                    <a:lstStyle/>
+                    <a:p>
+                      <a:pPr indent="0" marL="0">
+                        <a:buNone/>
+                      </a:pPr>
+                      <a:r>
+                        <a:rPr lang="en-US" sz="1300" dirty="0">
+                          <a:solidFill>
+                            <a:schemeClr val="tx1"/>
+                          </a:solidFill>
+                        </a:rPr>
+                        <a:t>Age (years since first 10-K)</a:t>
+                      </a:r>
+                      <a:endParaRPr lang="en-US" sz="1300" dirty="0"/>
+                    </a:p>
+                  </a:txBody>
+                  <a:tcPr marL="91440" marR="91440" marT="45720" marB="45720" anchor="ctr">
+                    <a:lnL w="6350" cap="flat" cmpd="sng" algn="ctr">
+                      <a:solidFill>
+                        <a:srgbClr val="D5DDE0"/>
+                      </a:solidFill>
+                      <a:prstDash val="solid"/>
+                      <a:round/>
+                      <a:headEnd type="none" w="med" len="med"/>
+                      <a:tailEnd type="none" w="med" len="med"/>
+                    </a:lnL>
+                    <a:lnR w="6350" cap="flat" cmpd="sng" algn="ctr">
+                      <a:solidFill>
+                        <a:srgbClr val="D5DDE0"/>
+                      </a:solidFill>
+                      <a:prstDash val="solid"/>
+                      <a:round/>
+                      <a:headEnd type="none" w="med" len="med"/>
+                      <a:tailEnd type="none" w="med" len="med"/>
+                    </a:lnR>
+                    <a:lnT w="6350" cap="flat" cmpd="sng" algn="ctr">
+                      <a:solidFill>
+                        <a:srgbClr val="D5DDE0"/>
+                      </a:solidFill>
+                      <a:prstDash val="solid"/>
+                      <a:round/>
+                      <a:headEnd type="none" w="med" len="med"/>
+                      <a:tailEnd type="none" w="med" len="med"/>
+                    </a:lnT>
+                    <a:lnB w="6350" cap="flat" cmpd="sng" algn="ctr">
+                      <a:solidFill>
+                        <a:srgbClr val="D5DDE0"/>
+                      </a:solidFill>
+                      <a:prstDash val="solid"/>
+                      <a:round/>
+                      <a:headEnd type="none" w="med" len="med"/>
+                      <a:tailEnd type="none" w="med" len="med"/>
+                    </a:lnB>
+                    <a:solidFill>
+                      <a:srgbClr val="FFFFFF"/>
+                    </a:solidFill>
+                  </a:tcPr>
+                </a:tc>
+                <a:tc>
+                  <a:txBody>
+                    <a:bodyPr/>
+                    <a:lstStyle/>
+                    <a:p>
+                      <a:pPr algn="r" indent="0" marL="0">
+                        <a:buNone/>
+                      </a:pPr>
+                      <a:r>
+                        <a:rPr lang="en-US" sz="1300" dirty="0">
+                          <a:solidFill>
+                            <a:schemeClr val="tx1"/>
+                          </a:solidFill>
+                        </a:rPr>
+                        <a:t>1.0</a:t>
+                      </a:r>
+                      <a:endParaRPr lang="en-US" sz="1300" dirty="0"/>
+                    </a:p>
+                  </a:txBody>
+                  <a:tcPr marL="91440" marR="91440" marT="45720" marB="45720" anchor="ctr">
+                    <a:lnL w="6350" cap="flat" cmpd="sng" algn="ctr">
+                      <a:solidFill>
+                        <a:srgbClr val="D5DDE0"/>
+                      </a:solidFill>
+                      <a:prstDash val="solid"/>
+                      <a:round/>
+                      <a:headEnd type="none" w="med" len="med"/>
+                      <a:tailEnd type="none" w="med" len="med"/>
+                    </a:lnL>
+                    <a:lnR w="6350" cap="flat" cmpd="sng" algn="ctr">
+                      <a:solidFill>
+                        <a:srgbClr val="D5DDE0"/>
+                      </a:solidFill>
+                      <a:prstDash val="solid"/>
+                      <a:round/>
+                      <a:headEnd type="none" w="med" len="med"/>
+                      <a:tailEnd type="none" w="med" len="med"/>
+                    </a:lnR>
+                    <a:lnT w="6350" cap="flat" cmpd="sng" algn="ctr">
+                      <a:solidFill>
+                        <a:srgbClr val="D5DDE0"/>
+                      </a:solidFill>
+                      <a:prstDash val="solid"/>
+                      <a:round/>
+                      <a:headEnd type="none" w="med" len="med"/>
+                      <a:tailEnd type="none" w="med" len="med"/>
+                    </a:lnT>
+                    <a:lnB w="6350" cap="flat" cmpd="sng" algn="ctr">
+                      <a:solidFill>
+                        <a:srgbClr val="D5DDE0"/>
+                      </a:solidFill>
+                      <a:prstDash val="solid"/>
+                      <a:round/>
+                      <a:headEnd type="none" w="med" len="med"/>
+                      <a:tailEnd type="none" w="med" len="med"/>
+                    </a:lnB>
+                    <a:solidFill>
+                      <a:srgbClr val="FFFFFF"/>
+                    </a:solidFill>
+                  </a:tcPr>
+                </a:tc>
+                <a:tc>
+                  <a:txBody>
+                    <a:bodyPr/>
+                    <a:lstStyle/>
+                    <a:p>
+                      <a:pPr algn="r" indent="0" marL="0">
+                        <a:buNone/>
+                      </a:pPr>
+                      <a:r>
+                        <a:rPr lang="en-US" sz="1300" dirty="0">
+                          <a:solidFill>
+                            <a:schemeClr val="tx1"/>
+                          </a:solidFill>
+                        </a:rPr>
+                        <a:t>15.0</a:t>
+                      </a:r>
+                      <a:endParaRPr lang="en-US" sz="1300" dirty="0"/>
+                    </a:p>
+                  </a:txBody>
+                  <a:tcPr marL="91440" marR="91440" marT="45720" marB="45720" anchor="ctr">
+                    <a:lnL w="6350" cap="flat" cmpd="sng" algn="ctr">
+                      <a:solidFill>
+                        <a:srgbClr val="D5DDE0"/>
+                      </a:solidFill>
+                      <a:prstDash val="solid"/>
+                      <a:round/>
+                      <a:headEnd type="none" w="med" len="med"/>
+                      <a:tailEnd type="none" w="med" len="med"/>
+                    </a:lnL>
+                    <a:lnR w="6350" cap="flat" cmpd="sng" algn="ctr">
+                      <a:solidFill>
+                        <a:srgbClr val="D5DDE0"/>
+                      </a:solidFill>
+                      <a:prstDash val="solid"/>
+                      <a:round/>
+                      <a:headEnd type="none" w="med" len="med"/>
+                      <a:tailEnd type="none" w="med" len="med"/>
+                    </a:lnR>
+                    <a:lnT w="6350" cap="flat" cmpd="sng" algn="ctr">
+                      <a:solidFill>
+                        <a:srgbClr val="D5DDE0"/>
+                      </a:solidFill>
+                      <a:prstDash val="solid"/>
+                      <a:round/>
+                      <a:headEnd type="none" w="med" len="med"/>
+                      <a:tailEnd type="none" w="med" len="med"/>
+                    </a:lnT>
+                    <a:lnB w="6350" cap="flat" cmpd="sng" algn="ctr">
+                      <a:solidFill>
+                        <a:srgbClr val="D5DDE0"/>
+                      </a:solidFill>
+                      <a:prstDash val="solid"/>
+                      <a:round/>
+                      <a:headEnd type="none" w="med" len="med"/>
+                      <a:tailEnd type="none" w="med" len="med"/>
+                    </a:lnB>
+                    <a:solidFill>
+                      <a:srgbClr val="FFFFFF"/>
+                    </a:solidFill>
+                  </a:tcPr>
+                </a:tc>
+                <a:tc>
+                  <a:txBody>
+                    <a:bodyPr/>
+                    <a:lstStyle/>
+                    <a:p>
+                      <a:pPr algn="r" indent="0" marL="0">
+                        <a:buNone/>
+                      </a:pPr>
+                      <a:r>
+                        <a:rPr lang="en-US" sz="1300" dirty="0">
+                          <a:solidFill>
+                            <a:schemeClr val="tx1"/>
+                          </a:solidFill>
+                        </a:rPr>
+                        <a:t>16.2</a:t>
+                      </a:r>
+                      <a:endParaRPr lang="en-US" sz="1300" dirty="0"/>
+                    </a:p>
+                  </a:txBody>
+                  <a:tcPr marL="91440" marR="91440" marT="45720" marB="45720" anchor="ctr">
+                    <a:lnL w="6350" cap="flat" cmpd="sng" algn="ctr">
+                      <a:solidFill>
+                        <a:srgbClr val="D5DDE0"/>
+                      </a:solidFill>
+                      <a:prstDash val="solid"/>
+                      <a:round/>
+                      <a:headEnd type="none" w="med" len="med"/>
+                      <a:tailEnd type="none" w="med" len="med"/>
+                    </a:lnL>
+                    <a:lnR w="6350" cap="flat" cmpd="sng" algn="ctr">
+                      <a:solidFill>
+                        <a:srgbClr val="D5DDE0"/>
+                      </a:solidFill>
+                      <a:prstDash val="solid"/>
+                      <a:round/>
+                      <a:headEnd type="none" w="med" len="med"/>
+                      <a:tailEnd type="none" w="med" len="med"/>
+                    </a:lnR>
+                    <a:lnT w="6350" cap="flat" cmpd="sng" algn="ctr">
+                      <a:solidFill>
+                        <a:srgbClr val="D5DDE0"/>
+                      </a:solidFill>
+                      <a:prstDash val="solid"/>
+                      <a:round/>
+                      <a:headEnd type="none" w="med" len="med"/>
+                      <a:tailEnd type="none" w="med" len="med"/>
+                    </a:lnT>
+                    <a:lnB w="6350" cap="flat" cmpd="sng" algn="ctr">
+                      <a:solidFill>
+                        <a:srgbClr val="D5DDE0"/>
+                      </a:solidFill>
+                      <a:prstDash val="solid"/>
+                      <a:round/>
+                      <a:headEnd type="none" w="med" len="med"/>
+                      <a:tailEnd type="none" w="med" len="med"/>
+                    </a:lnB>
+                    <a:solidFill>
+                      <a:srgbClr val="FFFFFF"/>
+                    </a:solidFill>
+                  </a:tcPr>
+                </a:tc>
+                <a:tc>
+                  <a:txBody>
+                    <a:bodyPr/>
+                    <a:lstStyle/>
+                    <a:p>
+                      <a:pPr algn="r" indent="0" marL="0">
+                        <a:buNone/>
+                      </a:pPr>
+                      <a:r>
+                        <a:rPr lang="en-US" sz="1300" dirty="0">
+                          <a:solidFill>
+                            <a:schemeClr val="tx1"/>
+                          </a:solidFill>
+                        </a:rPr>
+                        <a:t>41.8</a:t>
+                      </a:r>
+                      <a:endParaRPr lang="en-US" sz="1300" dirty="0"/>
+                    </a:p>
+                  </a:txBody>
+                  <a:tcPr marL="91440" marR="91440" marT="45720" marB="45720" anchor="ctr">
+                    <a:lnL w="6350" cap="flat" cmpd="sng" algn="ctr">
+                      <a:solidFill>
+                        <a:srgbClr val="D5DDE0"/>
+                      </a:solidFill>
+                      <a:prstDash val="solid"/>
+                      <a:round/>
+                      <a:headEnd type="none" w="med" len="med"/>
+                      <a:tailEnd type="none" w="med" len="med"/>
+                    </a:lnL>
+                    <a:lnR w="6350" cap="flat" cmpd="sng" algn="ctr">
+                      <a:solidFill>
+                        <a:srgbClr val="D5DDE0"/>
+                      </a:solidFill>
+                      <a:prstDash val="solid"/>
+                      <a:round/>
+                      <a:headEnd type="none" w="med" len="med"/>
+                      <a:tailEnd type="none" w="med" len="med"/>
+                    </a:lnR>
+                    <a:lnT w="6350" cap="flat" cmpd="sng" algn="ctr">
+                      <a:solidFill>
+                        <a:srgbClr val="D5DDE0"/>
+                      </a:solidFill>
+                      <a:prstDash val="solid"/>
+                      <a:round/>
+                      <a:headEnd type="none" w="med" len="med"/>
+                      <a:tailEnd type="none" w="med" len="med"/>
+                    </a:lnT>
+                    <a:lnB w="6350" cap="flat" cmpd="sng" algn="ctr">
+                      <a:solidFill>
+                        <a:srgbClr val="D5DDE0"/>
+                      </a:solidFill>
+                      <a:prstDash val="solid"/>
+                      <a:round/>
+                      <a:headEnd type="none" w="med" len="med"/>
+                      <a:tailEnd type="none" w="med" len="med"/>
+                    </a:lnB>
+                    <a:solidFill>
+                      <a:srgbClr val="FFFFFF"/>
+                    </a:solidFill>
+                  </a:tcPr>
+                </a:tc>
+              </a:tr>
+              <a:tr h="384048">
+                <a:tc>
+                  <a:txBody>
+                    <a:bodyPr/>
+                    <a:lstStyle/>
+                    <a:p>
+                      <a:pPr indent="0" marL="0">
+                        <a:buNone/>
+                      </a:pPr>
+                      <a:r>
+                        <a:rPr lang="en-US" sz="1300" dirty="0">
+                          <a:solidFill>
+                            <a:schemeClr val="tx1"/>
+                          </a:solidFill>
+                        </a:rPr>
+                        <a:t>Revenue ($ millions)</a:t>
+                      </a:r>
+                      <a:endParaRPr lang="en-US" sz="1300" dirty="0"/>
+                    </a:p>
+                  </a:txBody>
+                  <a:tcPr marL="91440" marR="91440" marT="45720" marB="45720" anchor="ctr">
+                    <a:lnL w="6350" cap="flat" cmpd="sng" algn="ctr">
+                      <a:solidFill>
+                        <a:srgbClr val="D5DDE0"/>
+                      </a:solidFill>
+                      <a:prstDash val="solid"/>
+                      <a:round/>
+                      <a:headEnd type="none" w="med" len="med"/>
+                      <a:tailEnd type="none" w="med" len="med"/>
+                    </a:lnL>
+                    <a:lnR w="6350" cap="flat" cmpd="sng" algn="ctr">
+                      <a:solidFill>
+                        <a:srgbClr val="D5DDE0"/>
+                      </a:solidFill>
+                      <a:prstDash val="solid"/>
+                      <a:round/>
+                      <a:headEnd type="none" w="med" len="med"/>
+                      <a:tailEnd type="none" w="med" len="med"/>
+                    </a:lnR>
+                    <a:lnT w="6350" cap="flat" cmpd="sng" algn="ctr">
+                      <a:solidFill>
+                        <a:srgbClr val="D5DDE0"/>
+                      </a:solidFill>
+                      <a:prstDash val="solid"/>
+                      <a:round/>
+                      <a:headEnd type="none" w="med" len="med"/>
+                      <a:tailEnd type="none" w="med" len="med"/>
+                    </a:lnT>
+                    <a:lnB w="6350" cap="flat" cmpd="sng" algn="ctr">
+                      <a:solidFill>
+                        <a:srgbClr val="D5DDE0"/>
+                      </a:solidFill>
+                      <a:prstDash val="solid"/>
+                      <a:round/>
+                      <a:headEnd type="none" w="med" len="med"/>
+                      <a:tailEnd type="none" w="med" len="med"/>
+                    </a:lnB>
+                    <a:solidFill>
+                      <a:srgbClr val="FFFFFF"/>
+                    </a:solidFill>
+                  </a:tcPr>
+                </a:tc>
+                <a:tc>
+                  <a:txBody>
+                    <a:bodyPr/>
+                    <a:lstStyle/>
+                    <a:p>
+                      <a:pPr algn="r" indent="0" marL="0">
+                        <a:buNone/>
+                      </a:pPr>
+                      <a:r>
+                        <a:rPr lang="en-US" sz="1300" dirty="0">
+                          <a:solidFill>
+                            <a:schemeClr val="tx1"/>
+                          </a:solidFill>
+                        </a:rPr>
+                        <a:t>100</a:t>
+                      </a:r>
+                      <a:endParaRPr lang="en-US" sz="1300" dirty="0"/>
+                    </a:p>
+                  </a:txBody>
+                  <a:tcPr marL="91440" marR="91440" marT="45720" marB="45720" anchor="ctr">
+                    <a:lnL w="6350" cap="flat" cmpd="sng" algn="ctr">
+                      <a:solidFill>
+                        <a:srgbClr val="D5DDE0"/>
+                      </a:solidFill>
+                      <a:prstDash val="solid"/>
+                      <a:round/>
+                      <a:headEnd type="none" w="med" len="med"/>
+                      <a:tailEnd type="none" w="med" len="med"/>
+                    </a:lnL>
+                    <a:lnR w="6350" cap="flat" cmpd="sng" algn="ctr">
+                      <a:solidFill>
+                        <a:srgbClr val="D5DDE0"/>
+                      </a:solidFill>
+                      <a:prstDash val="solid"/>
+                      <a:round/>
+                      <a:headEnd type="none" w="med" len="med"/>
+                      <a:tailEnd type="none" w="med" len="med"/>
+                    </a:lnR>
+                    <a:lnT w="6350" cap="flat" cmpd="sng" algn="ctr">
+                      <a:solidFill>
+                        <a:srgbClr val="D5DDE0"/>
+                      </a:solidFill>
+                      <a:prstDash val="solid"/>
+                      <a:round/>
+                      <a:headEnd type="none" w="med" len="med"/>
+                      <a:tailEnd type="none" w="med" len="med"/>
+                    </a:lnT>
+                    <a:lnB w="6350" cap="flat" cmpd="sng" algn="ctr">
+                      <a:solidFill>
+                        <a:srgbClr val="D5DDE0"/>
+                      </a:solidFill>
+                      <a:prstDash val="solid"/>
+                      <a:round/>
+                      <a:headEnd type="none" w="med" len="med"/>
+                      <a:tailEnd type="none" w="med" len="med"/>
+                    </a:lnB>
+                    <a:solidFill>
+                      <a:srgbClr val="FFFFFF"/>
+                    </a:solidFill>
+                  </a:tcPr>
+                </a:tc>
+                <a:tc>
+                  <a:txBody>
+                    <a:bodyPr/>
+                    <a:lstStyle/>
+                    <a:p>
+                      <a:pPr algn="r" indent="0" marL="0">
+                        <a:buNone/>
+                      </a:pPr>
+                      <a:r>
+                        <a:rPr lang="en-US" sz="1300" dirty="0">
+                          <a:solidFill>
+                            <a:schemeClr val="tx1"/>
+                          </a:solidFill>
+                        </a:rPr>
+                        <a:t>317</a:t>
+                      </a:r>
+                      <a:endParaRPr lang="en-US" sz="1300" dirty="0"/>
+                    </a:p>
+                  </a:txBody>
+                  <a:tcPr marL="91440" marR="91440" marT="45720" marB="45720" anchor="ctr">
+                    <a:lnL w="6350" cap="flat" cmpd="sng" algn="ctr">
+                      <a:solidFill>
+                        <a:srgbClr val="D5DDE0"/>
+                      </a:solidFill>
+                      <a:prstDash val="solid"/>
+                      <a:round/>
+                      <a:headEnd type="none" w="med" len="med"/>
+                      <a:tailEnd type="none" w="med" len="med"/>
+                    </a:lnL>
+                    <a:lnR w="6350" cap="flat" cmpd="sng" algn="ctr">
+                      <a:solidFill>
+                        <a:srgbClr val="D5DDE0"/>
+                      </a:solidFill>
+                      <a:prstDash val="solid"/>
+                      <a:round/>
+                      <a:headEnd type="none" w="med" len="med"/>
+                      <a:tailEnd type="none" w="med" len="med"/>
+                    </a:lnR>
+                    <a:lnT w="6350" cap="flat" cmpd="sng" algn="ctr">
+                      <a:solidFill>
+                        <a:srgbClr val="D5DDE0"/>
+                      </a:solidFill>
+                      <a:prstDash val="solid"/>
+                      <a:round/>
+                      <a:headEnd type="none" w="med" len="med"/>
+                      <a:tailEnd type="none" w="med" len="med"/>
+                    </a:lnT>
+                    <a:lnB w="6350" cap="flat" cmpd="sng" algn="ctr">
+                      <a:solidFill>
+                        <a:srgbClr val="D5DDE0"/>
+                      </a:solidFill>
+                      <a:prstDash val="solid"/>
+                      <a:round/>
+                      <a:headEnd type="none" w="med" len="med"/>
+                      <a:tailEnd type="none" w="med" len="med"/>
+                    </a:lnB>
+                    <a:solidFill>
+                      <a:srgbClr val="FFFFFF"/>
+                    </a:solidFill>
+                  </a:tcPr>
+                </a:tc>
+                <a:tc>
+                  <a:txBody>
+                    <a:bodyPr/>
+                    <a:lstStyle/>
+                    <a:p>
+                      <a:pPr algn="r" indent="0" marL="0">
+                        <a:buNone/>
+                      </a:pPr>
+                      <a:r>
+                        <a:rPr lang="en-US" sz="1300" dirty="0">
+                          <a:solidFill>
+                            <a:schemeClr val="tx1"/>
+                          </a:solidFill>
+                        </a:rPr>
+                        <a:t>2,469</a:t>
+                      </a:r>
+                      <a:endParaRPr lang="en-US" sz="1300" dirty="0"/>
+                    </a:p>
+                  </a:txBody>
+                  <a:tcPr marL="91440" marR="91440" marT="45720" marB="45720" anchor="ctr">
+                    <a:lnL w="6350" cap="flat" cmpd="sng" algn="ctr">
+                      <a:solidFill>
+                        <a:srgbClr val="D5DDE0"/>
+                      </a:solidFill>
+                      <a:prstDash val="solid"/>
+                      <a:round/>
+                      <a:headEnd type="none" w="med" len="med"/>
+                      <a:tailEnd type="none" w="med" len="med"/>
+                    </a:lnL>
+                    <a:lnR w="6350" cap="flat" cmpd="sng" algn="ctr">
+                      <a:solidFill>
+                        <a:srgbClr val="D5DDE0"/>
+                      </a:solidFill>
+                      <a:prstDash val="solid"/>
+                      <a:round/>
+                      <a:headEnd type="none" w="med" len="med"/>
+                      <a:tailEnd type="none" w="med" len="med"/>
+                    </a:lnR>
+                    <a:lnT w="6350" cap="flat" cmpd="sng" algn="ctr">
+                      <a:solidFill>
+                        <a:srgbClr val="D5DDE0"/>
+                      </a:solidFill>
+                      <a:prstDash val="solid"/>
+                      <a:round/>
+                      <a:headEnd type="none" w="med" len="med"/>
+                      <a:tailEnd type="none" w="med" len="med"/>
+                    </a:lnT>
+                    <a:lnB w="6350" cap="flat" cmpd="sng" algn="ctr">
+                      <a:solidFill>
+                        <a:srgbClr val="D5DDE0"/>
+                      </a:solidFill>
+                      <a:prstDash val="solid"/>
+                      <a:round/>
+                      <a:headEnd type="none" w="med" len="med"/>
+                      <a:tailEnd type="none" w="med" len="med"/>
+                    </a:lnB>
+                    <a:solidFill>
+                      <a:srgbClr val="FFFFFF"/>
+                    </a:solidFill>
+                  </a:tcPr>
+                </a:tc>
+                <a:tc>
+                  <a:txBody>
+                    <a:bodyPr/>
+                    <a:lstStyle/>
+                    <a:p>
+                      <a:pPr algn="r" indent="0" marL="0">
+                        <a:buNone/>
+                      </a:pPr>
+                      <a:r>
+                        <a:rPr lang="en-US" sz="1300" dirty="0">
+                          <a:solidFill>
+                            <a:schemeClr val="tx1"/>
+                          </a:solidFill>
+                        </a:rPr>
+                        <a:t>58,054</a:t>
+                      </a:r>
+                      <a:endParaRPr lang="en-US" sz="1300" dirty="0"/>
+                    </a:p>
+                  </a:txBody>
+                  <a:tcPr marL="91440" marR="91440" marT="45720" marB="45720" anchor="ctr">
+                    <a:lnL w="6350" cap="flat" cmpd="sng" algn="ctr">
+                      <a:solidFill>
+                        <a:srgbClr val="D5DDE0"/>
+                      </a:solidFill>
+                      <a:prstDash val="solid"/>
+                      <a:round/>
+                      <a:headEnd type="none" w="med" len="med"/>
+                      <a:tailEnd type="none" w="med" len="med"/>
+                    </a:lnL>
+                    <a:lnR w="6350" cap="flat" cmpd="sng" algn="ctr">
+                      <a:solidFill>
+                        <a:srgbClr val="D5DDE0"/>
+                      </a:solidFill>
+                      <a:prstDash val="solid"/>
+                      <a:round/>
+                      <a:headEnd type="none" w="med" len="med"/>
+                      <a:tailEnd type="none" w="med" len="med"/>
+                    </a:lnR>
+                    <a:lnT w="6350" cap="flat" cmpd="sng" algn="ctr">
+                      <a:solidFill>
+                        <a:srgbClr val="D5DDE0"/>
+                      </a:solidFill>
+                      <a:prstDash val="solid"/>
+                      <a:round/>
+                      <a:headEnd type="none" w="med" len="med"/>
+                      <a:tailEnd type="none" w="med" len="med"/>
+                    </a:lnT>
+                    <a:lnB w="6350" cap="flat" cmpd="sng" algn="ctr">
+                      <a:solidFill>
+                        <a:srgbClr val="D5DDE0"/>
+                      </a:solidFill>
+                      <a:prstDash val="solid"/>
+                      <a:round/>
+                      <a:headEnd type="none" w="med" len="med"/>
+                      <a:tailEnd type="none" w="med" len="med"/>
+                    </a:lnB>
+                    <a:solidFill>
+                      <a:srgbClr val="FFFFFF"/>
+                    </a:solidFill>
+                  </a:tcPr>
+                </a:tc>
+              </a:tr>
+            </a:tbl>
+          </a:graphicData>
+        </a:graphic>
+      </p:graphicFrame>
+      <p:sp>
+        <p:nvSpPr>
+          <p:cNvPr id="4" name="Text 1"/>
+          <p:cNvSpPr txBox="1"/>
+          <p:nvPr/>
+        </p:nvSpPr>
+        <p:spPr>
+          <a:xfrm>
+            <a:off x="548640" y="3154680"/>
+            <a:ext cx="6583680" cy="640080"/>
+          </a:xfrm>
+          <a:prstGeom prst="rect">
+            <a:avLst/>
+          </a:prstGeom>
+          <a:noFill/>
+          <a:ln/>
+        </p:spPr>
+        <p:txBody>
+          <a:bodyPr wrap="square" lIns="0" tIns="0" rIns="0" bIns="0" rtlCol="0" anchor="t"/>
+          <a:lstStyle/>
+          <a:p>
+            <a:pPr indent="0" marL="0">
+              <a:buNone/>
+            </a:pPr>
+            <a:r>
+              <a:rPr lang="en-US" sz="1300" dirty="0">
+                <a:solidFill>
+                  <a:schemeClr val="tx1"/>
+                </a:solidFill>
+              </a:rPr>
+              <a:t>n = 833 company-years (201 firms). MVE is strongly right-skewed (mean about 5× the median), which is why the charts use a log axis.</a:t>
+            </a:r>
+            <a:endParaRPr lang="en-US" sz="1300" dirty="0"/>
+          </a:p>
+        </p:txBody>
+      </p:sp>
+      <p:sp>
+        <p:nvSpPr>
+          <p:cNvPr id="5" name="Text 2"/>
+          <p:cNvSpPr txBox="1"/>
+          <p:nvPr/>
+        </p:nvSpPr>
+        <p:spPr>
+          <a:xfrm>
+            <a:off x="7498080" y="1371600"/>
+            <a:ext cx="4142232" cy="320040"/>
+          </a:xfrm>
+          <a:prstGeom prst="rect">
+            <a:avLst/>
+          </a:prstGeom>
+          <a:noFill/>
+          <a:ln/>
+        </p:spPr>
+        <p:txBody>
+          <a:bodyPr wrap="square" lIns="0" tIns="0" rIns="0" bIns="0" rtlCol="0" anchor="ctr"/>
+          <a:lstStyle/>
+          <a:p>
+            <a:pPr indent="0" marL="0">
+              <a:buNone/>
+            </a:pPr>
+            <a:r>
+              <a:rPr lang="en-US" sz="1600" b="1" dirty="0">
+                <a:solidFill>
+                  <a:schemeClr val="tx2"/>
+                </a:solidFill>
+              </a:rPr>
+              <a:t>Method notes</a:t>
+            </a:r>
+            <a:endParaRPr lang="en-US" sz="1600" dirty="0"/>
+          </a:p>
+        </p:txBody>
+      </p:sp>
+      <p:sp>
+        <p:nvSpPr>
+          <p:cNvPr id="6" name="Text 3"/>
+          <p:cNvSpPr txBox="1"/>
+          <p:nvPr/>
+        </p:nvSpPr>
+        <p:spPr>
+          <a:xfrm>
+            <a:off x="7498080" y="1737360"/>
+            <a:ext cx="4142232" cy="4480560"/>
+          </a:xfrm>
+          <a:prstGeom prst="rect">
+            <a:avLst/>
+          </a:prstGeom>
+          <a:noFill/>
+          <a:ln/>
+        </p:spPr>
+        <p:txBody>
+          <a:bodyPr wrap="square" lIns="0" tIns="0" rIns="0" bIns="0" rtlCol="0" anchor="t"/>
+          <a:lstStyle/>
+          <a:p>
+            <a:pPr marL="203200" indent="-203200">
+              <a:spcAft>
+                <a:spcPts val="600"/>
+              </a:spcAft>
+              <a:buSzPct val="100000"/>
+              <a:buChar char="•"/>
+            </a:pPr>
+            <a:r>
+              <a:rPr lang="en-US" sz="1400" dirty="0">
+                <a:solidFill>
+                  <a:schemeClr val="tx1"/>
+                </a:solidFill>
+              </a:rPr>
+              <a:t>Trend line: LOESS of log(MVE) on age, span 0.4, drawn over the 1st–99th percentile of age</a:t>
+            </a:r>
+            <a:endParaRPr lang="en-US" sz="1400" dirty="0"/>
+          </a:p>
+          <a:p>
+            <a:pPr marL="203200" indent="-203200">
+              <a:spcAft>
+                <a:spcPts val="600"/>
+              </a:spcAft>
+              <a:buSzPct val="100000"/>
+              <a:buChar char="•"/>
+            </a:pPr>
+            <a:r>
+              <a:rPr lang="en-US" sz="1400" dirty="0">
+                <a:solidFill>
+                  <a:schemeClr val="tx1"/>
+                </a:solidFill>
+              </a:rPr>
+              <a:t>95% band: 300 resamples of whole firms, refitting each time</a:t>
+            </a:r>
+            <a:endParaRPr lang="en-US" sz="1400" dirty="0"/>
+          </a:p>
+          <a:p>
+            <a:pPr marL="203200" indent="-203200">
+              <a:spcAft>
+                <a:spcPts val="600"/>
+              </a:spcAft>
+              <a:buSzPct val="100000"/>
+              <a:buChar char="•"/>
+            </a:pPr>
+            <a:r>
+              <a:rPr lang="en-US" sz="1400" dirty="0">
+                <a:solidFill>
+                  <a:schemeClr val="tx1"/>
+                </a:solidFill>
+              </a:rPr>
+              <a:t>Axes: MVE log scale; R&amp;D / revenue linear; debt / equity symmetric-log (it has negative values)</a:t>
+            </a:r>
+            <a:endParaRPr lang="en-US" sz="1400" dirty="0"/>
+          </a:p>
+          <a:p>
+            <a:pPr marL="203200" indent="-203200">
+              <a:spcAft>
+                <a:spcPts val="600"/>
+              </a:spcAft>
+              <a:buSzPct val="100000"/>
+              <a:buChar char="•"/>
+            </a:pPr>
+            <a:r>
+              <a:rPr lang="en-US" sz="1400" dirty="0">
+                <a:solidFill>
+                  <a:schemeClr val="tx1"/>
+                </a:solidFill>
+              </a:rPr>
+              <a:t>Reproduce: see the README in the repository (Python scripts for the charts and this deck)</a:t>
+            </a:r>
+            <a:endParaRPr lang="en-US" sz="1400" dirty="0"/>
+          </a:p>
+        </p:txBody>
+      </p:sp>
+      <p:sp>
+        <p:nvSpPr>
+          <p:cNvPr id="25" name="Slide Number Placeholder 0"/>
+          <p:cNvSpPr>
+            <a:spLocks noGrp="1"/>
+          </p:cNvSpPr>
+          <p:nvPr>
+            <p:ph type="sldNum" sz="quarter" idx="4294967295"/>
+          </p:nvPr>
+        </p:nvSpPr>
+        <p:spPr>
+          <a:xfrm>
+            <a:off x="11183112" y="6446520"/>
+            <a:ext cx="457200" cy="274320"/>
+          </a:xfrm>
+          <a:prstGeom prst="rect">
+            <a:avLst/>
+          </a:prstGeom>
+          <a:extLst>
+            <a:ext uri="{C572A759-6A51-4108-AA02-DFA0A04FC94B}">
+              <ma14:wrappingTextBoxFlag xmlns:ma14="http://schemas.microsoft.com/office/mac/drawingml/2011/main" val="0"/>
+            </a:ext>
+          </a:extLst>
+        </p:spPr>
+        <p:txBody>
+          <a:bodyPr/>
+          <a:lstStyle>
+            <a:lvl1pPr>
+              <a:defRPr sz="1000">
+                <a:solidFill>
+                  <a:schemeClr val="accent3"/>
+                </a:solidFill>
+              </a:defRPr>
+            </a:lvl1pPr>
+          </a:lstStyle>
+          <a:p>
+            <a:pPr algn="r"/>
+            <a:fld id="{F7021451-1387-4CA6-816F-3879F97B5CBC}" type="slidenum">
+              <a:rPr b="0" lang="en-US"/>
+              <a:t>10</a:t>
+            </a:fld>
+            <a:endParaRPr lang="en-US"/>
+          </a:p>
+        </p:txBody>
+      </p:sp>
+    </p:spTree>
+  </p:cSld>
+  <p:clrMapOvr>
+    <a:masterClrMapping/>
+  </p:clrMapOvr>
+</p:sld>
+</file>
+
 <file path=ppt/slides/slide2.xml><?xml version="1.0" encoding="utf-8"?>
 <p:sld xmlns:a="http://schemas.openxmlformats.org/drawingml/2006/main" xmlns:r="http://schemas.openxmlformats.org/officeDocument/2006/relationships" xmlns:p="http://schemas.openxmlformats.org/presentationml/2006/main">
   <p:cSld name="Slide 2">
@@ -4081,7 +5709,7 @@
                   <a:schemeClr val="tx1"/>
                 </a:solidFill>
               </a:rPr>
-              <a:t>Revenue floor: only firm-years with revenue ≥ $100M (applied in the source file) so ratios are not distorted by tiny denominators</a:t>
+              <a:t>Revenue floor: only firm-years with revenue ≥ $100M (applied upstream) so ratios are not distorted by tiny denominators</a:t>
             </a:r>
             <a:endParaRPr lang="en-US" sz="1600" dirty="0"/>
           </a:p>
@@ -4099,7 +5727,7 @@
                   <a:schemeClr val="tx1"/>
                 </a:solidFill>
               </a:rPr>
-              <a:t>Missing data: none in the columns used; no imputation and no rows dropped</a:t>
+              <a:t>Missing data: none in the columns used; no imputation, and this analysis dropped no rows. Upstream filters on the full source table: Appendix A1</a:t>
             </a:r>
             <a:endParaRPr lang="en-US" sz="1600" dirty="0"/>
           </a:p>
@@ -4117,7 +5745,7 @@
                   <a:schemeClr val="tx1"/>
                 </a:solidFill>
               </a:rPr>
-              <a:t>Outliers: none removed and no winsorizing; 1% / 99% and 5% / 95% tests left the results unchanged (Appendix A1). Log axes handle the skew</a:t>
+              <a:t>Outliers: none removed and no winsorizing; 1% / 99% and 5% / 95% tests left the results unchanged (Appendix A2). Log axes handle the skew</a:t>
             </a:r>
             <a:endParaRPr lang="en-US" sz="1600" dirty="0"/>
           </a:p>
@@ -5873,15 +7501,721 @@
                 <a:ea typeface="Cambria" pitchFamily="34" charset="-122"/>
                 <a:cs typeface="Cambria" pitchFamily="34" charset="-120"/>
               </a:rPr>
-              <a:t>Appendix A1: Data cleaning choices and their effects</a:t>
+              <a:t>Appendix A1: Source data and upstream filters</a:t>
             </a:r>
             <a:endParaRPr lang="en-US" sz="3000" dirty="0"/>
           </a:p>
         </p:txBody>
       </p:sp>
+      <p:sp>
+        <p:nvSpPr>
+          <p:cNvPr id="3" name="Step card 1"/>
+          <p:cNvSpPr/>
+          <p:nvPr/>
+        </p:nvSpPr>
+        <p:spPr>
+          <a:xfrm>
+            <a:off x="548640" y="1371600"/>
+            <a:ext cx="3291840" cy="1920240"/>
+          </a:xfrm>
+          <a:prstGeom prst="roundRect">
+            <a:avLst>
+              <a:gd name="adj" fmla="val 3810"/>
+            </a:avLst>
+          </a:prstGeom>
+          <a:solidFill>
+            <a:schemeClr val="bg2"/>
+          </a:solidFill>
+          <a:ln w="12700">
+            <a:solidFill>
+              <a:schemeClr val="bg2"/>
+            </a:solidFill>
+            <a:prstDash val="solid"/>
+          </a:ln>
+        </p:spPr>
+      </p:sp>
+      <p:sp>
+        <p:nvSpPr>
+          <p:cNvPr id="4" name="Step 1 heading"/>
+          <p:cNvSpPr txBox="1"/>
+          <p:nvPr/>
+        </p:nvSpPr>
+        <p:spPr>
+          <a:xfrm>
+            <a:off x="731520" y="1481328"/>
+            <a:ext cx="2926080" cy="365760"/>
+          </a:xfrm>
+          <a:prstGeom prst="rect">
+            <a:avLst/>
+          </a:prstGeom>
+          <a:noFill/>
+          <a:ln/>
+        </p:spPr>
+        <p:txBody>
+          <a:bodyPr wrap="square" lIns="0" tIns="0" rIns="0" bIns="0" rtlCol="0" anchor="t"/>
+          <a:lstStyle/>
+          <a:p>
+            <a:pPr indent="0" marL="0">
+              <a:buNone/>
+            </a:pPr>
+            <a:r>
+              <a:rPr lang="en-US" sz="1400" b="1" dirty="0">
+                <a:solidFill>
+                  <a:schemeClr val="accent1"/>
+                </a:solidFill>
+              </a:rPr>
+              <a:t>Original source table</a:t>
+            </a:r>
+            <a:endParaRPr lang="en-US" sz="1400" dirty="0"/>
+          </a:p>
+        </p:txBody>
+      </p:sp>
+      <p:sp>
+        <p:nvSpPr>
+          <p:cNvPr id="5" name="Step 1 value"/>
+          <p:cNvSpPr txBox="1"/>
+          <p:nvPr/>
+        </p:nvSpPr>
+        <p:spPr>
+          <a:xfrm>
+            <a:off x="731520" y="1874520"/>
+            <a:ext cx="2926080" cy="640080"/>
+          </a:xfrm>
+          <a:prstGeom prst="rect">
+            <a:avLst/>
+          </a:prstGeom>
+          <a:noFill/>
+          <a:ln/>
+        </p:spPr>
+        <p:txBody>
+          <a:bodyPr wrap="square" lIns="0" tIns="0" rIns="0" bIns="0" rtlCol="0" anchor="ctr"/>
+          <a:lstStyle/>
+          <a:p>
+            <a:pPr indent="0" marL="0">
+              <a:buNone/>
+            </a:pPr>
+            <a:r>
+              <a:rPr lang="en-US" sz="3600" b="1" dirty="0">
+                <a:solidFill>
+                  <a:schemeClr val="tx2"/>
+                </a:solidFill>
+                <a:latin typeface="Cambria" pitchFamily="34" charset="0"/>
+                <a:ea typeface="Cambria" pitchFamily="34" charset="-122"/>
+                <a:cs typeface="Cambria" pitchFamily="34" charset="-120"/>
+              </a:rPr>
+              <a:t>100,000+</a:t>
+            </a:r>
+            <a:endParaRPr lang="en-US" sz="3600" dirty="0"/>
+          </a:p>
+        </p:txBody>
+      </p:sp>
+      <p:sp>
+        <p:nvSpPr>
+          <p:cNvPr id="6" name="Step 1 label"/>
+          <p:cNvSpPr txBox="1"/>
+          <p:nvPr/>
+        </p:nvSpPr>
+        <p:spPr>
+          <a:xfrm>
+            <a:off x="731520" y="2560320"/>
+            <a:ext cx="2926080" cy="640080"/>
+          </a:xfrm>
+          <a:prstGeom prst="rect">
+            <a:avLst/>
+          </a:prstGeom>
+          <a:noFill/>
+          <a:ln/>
+        </p:spPr>
+        <p:txBody>
+          <a:bodyPr wrap="square" lIns="0" tIns="0" rIns="0" bIns="0" rtlCol="0" anchor="t"/>
+          <a:lstStyle/>
+          <a:p>
+            <a:pPr indent="0" marL="0">
+              <a:buNone/>
+            </a:pPr>
+            <a:r>
+              <a:rPr lang="en-US" sz="1400" dirty="0">
+                <a:solidFill>
+                  <a:schemeClr val="tx1"/>
+                </a:solidFill>
+              </a:rPr>
+              <a:t>lines of data, all available columns</a:t>
+            </a:r>
+            <a:endParaRPr lang="en-US" sz="1400" dirty="0"/>
+          </a:p>
+        </p:txBody>
+      </p:sp>
+      <p:sp>
+        <p:nvSpPr>
+          <p:cNvPr id="7" name="Step arrow 1"/>
+          <p:cNvSpPr/>
+          <p:nvPr/>
+        </p:nvSpPr>
+        <p:spPr>
+          <a:xfrm>
+            <a:off x="3938778" y="2103120"/>
+            <a:ext cx="411480" cy="457200"/>
+          </a:xfrm>
+          <a:prstGeom prst="rightArrow">
+            <a:avLst/>
+          </a:prstGeom>
+          <a:solidFill>
+            <a:schemeClr val="accent2"/>
+          </a:solidFill>
+          <a:ln w="12700">
+            <a:solidFill>
+              <a:schemeClr val="accent2"/>
+            </a:solidFill>
+            <a:prstDash val="solid"/>
+          </a:ln>
+        </p:spPr>
+      </p:sp>
+      <p:sp>
+        <p:nvSpPr>
+          <p:cNvPr id="8" name="Step card 2"/>
+          <p:cNvSpPr/>
+          <p:nvPr/>
+        </p:nvSpPr>
+        <p:spPr>
+          <a:xfrm>
+            <a:off x="4448556" y="1371600"/>
+            <a:ext cx="3291840" cy="1920240"/>
+          </a:xfrm>
+          <a:prstGeom prst="roundRect">
+            <a:avLst>
+              <a:gd name="adj" fmla="val 3810"/>
+            </a:avLst>
+          </a:prstGeom>
+          <a:solidFill>
+            <a:schemeClr val="tx2"/>
+          </a:solidFill>
+          <a:ln w="12700">
+            <a:solidFill>
+              <a:schemeClr val="tx2"/>
+            </a:solidFill>
+            <a:prstDash val="solid"/>
+          </a:ln>
+        </p:spPr>
+      </p:sp>
+      <p:sp>
+        <p:nvSpPr>
+          <p:cNvPr id="9" name="Step 2 heading"/>
+          <p:cNvSpPr txBox="1"/>
+          <p:nvPr/>
+        </p:nvSpPr>
+        <p:spPr>
+          <a:xfrm>
+            <a:off x="4631436" y="1481328"/>
+            <a:ext cx="2926080" cy="365760"/>
+          </a:xfrm>
+          <a:prstGeom prst="rect">
+            <a:avLst/>
+          </a:prstGeom>
+          <a:noFill/>
+          <a:ln/>
+        </p:spPr>
+        <p:txBody>
+          <a:bodyPr wrap="square" lIns="0" tIns="0" rIns="0" bIns="0" rtlCol="0" anchor="t"/>
+          <a:lstStyle/>
+          <a:p>
+            <a:pPr indent="0" marL="0">
+              <a:buNone/>
+            </a:pPr>
+            <a:r>
+              <a:rPr lang="en-US" sz="1400" b="1" dirty="0">
+                <a:solidFill>
+                  <a:schemeClr val="accent4"/>
+                </a:solidFill>
+              </a:rPr>
+              <a:t>Filters applied before this analysis</a:t>
+            </a:r>
+            <a:endParaRPr lang="en-US" sz="1400" dirty="0"/>
+          </a:p>
+        </p:txBody>
+      </p:sp>
+      <p:sp>
+        <p:nvSpPr>
+          <p:cNvPr id="10" name="Step 2 filters"/>
+          <p:cNvSpPr txBox="1"/>
+          <p:nvPr/>
+        </p:nvSpPr>
+        <p:spPr>
+          <a:xfrm>
+            <a:off x="4631436" y="1920240"/>
+            <a:ext cx="2926080" cy="1280160"/>
+          </a:xfrm>
+          <a:prstGeom prst="rect">
+            <a:avLst/>
+          </a:prstGeom>
+          <a:noFill/>
+          <a:ln/>
+        </p:spPr>
+        <p:txBody>
+          <a:bodyPr wrap="square" lIns="0" tIns="0" rIns="0" bIns="0" rtlCol="0" anchor="t"/>
+          <a:lstStyle/>
+          <a:p>
+            <a:pPr marL="203200" indent="-203200">
+              <a:spcAft>
+                <a:spcPts val="600"/>
+              </a:spcAft>
+              <a:buSzPct val="100000"/>
+              <a:buChar char="•"/>
+            </a:pPr>
+            <a:r>
+              <a:rPr lang="en-US" sz="1500" dirty="0">
+                <a:solidFill>
+                  <a:schemeClr val="bg1"/>
+                </a:solidFill>
+              </a:rPr>
+              <a:t>Removed rows with zero total debt</a:t>
+            </a:r>
+            <a:endParaRPr lang="en-US" sz="1500" dirty="0"/>
+          </a:p>
+          <a:p>
+            <a:pPr marL="203200" indent="-203200">
+              <a:spcAft>
+                <a:spcPts val="600"/>
+              </a:spcAft>
+              <a:buSzPct val="100000"/>
+              <a:buChar char="•"/>
+            </a:pPr>
+            <a:r>
+              <a:rPr lang="en-US" sz="1500" dirty="0">
+                <a:solidFill>
+                  <a:schemeClr val="bg1"/>
+                </a:solidFill>
+              </a:rPr>
+              <a:t>Removed rows with blank capex</a:t>
+            </a:r>
+            <a:endParaRPr lang="en-US" sz="1500" dirty="0"/>
+          </a:p>
+          <a:p>
+            <a:pPr marL="203200" indent="-203200">
+              <a:spcAft>
+                <a:spcPts val="600"/>
+              </a:spcAft>
+              <a:buSzPct val="100000"/>
+              <a:buChar char="•"/>
+            </a:pPr>
+            <a:r>
+              <a:rPr lang="en-US" sz="1500" dirty="0">
+                <a:solidFill>
+                  <a:schemeClr val="bg1"/>
+                </a:solidFill>
+              </a:rPr>
+              <a:t>Kept revenue ≥ $100M</a:t>
+            </a:r>
+            <a:endParaRPr lang="en-US" sz="1500" dirty="0"/>
+          </a:p>
+        </p:txBody>
+      </p:sp>
+      <p:sp>
+        <p:nvSpPr>
+          <p:cNvPr id="11" name="Step arrow 2"/>
+          <p:cNvSpPr/>
+          <p:nvPr/>
+        </p:nvSpPr>
+        <p:spPr>
+          <a:xfrm>
+            <a:off x="7838694" y="2103120"/>
+            <a:ext cx="411480" cy="457200"/>
+          </a:xfrm>
+          <a:prstGeom prst="rightArrow">
+            <a:avLst/>
+          </a:prstGeom>
+          <a:solidFill>
+            <a:schemeClr val="accent2"/>
+          </a:solidFill>
+          <a:ln w="12700">
+            <a:solidFill>
+              <a:schemeClr val="accent2"/>
+            </a:solidFill>
+            <a:prstDash val="solid"/>
+          </a:ln>
+        </p:spPr>
+      </p:sp>
+      <p:sp>
+        <p:nvSpPr>
+          <p:cNvPr id="12" name="Step card 3"/>
+          <p:cNvSpPr/>
+          <p:nvPr/>
+        </p:nvSpPr>
+        <p:spPr>
+          <a:xfrm>
+            <a:off x="8348472" y="1371600"/>
+            <a:ext cx="3291840" cy="1920240"/>
+          </a:xfrm>
+          <a:prstGeom prst="roundRect">
+            <a:avLst>
+              <a:gd name="adj" fmla="val 3810"/>
+            </a:avLst>
+          </a:prstGeom>
+          <a:solidFill>
+            <a:schemeClr val="bg2"/>
+          </a:solidFill>
+          <a:ln w="12700">
+            <a:solidFill>
+              <a:schemeClr val="bg2"/>
+            </a:solidFill>
+            <a:prstDash val="solid"/>
+          </a:ln>
+        </p:spPr>
+      </p:sp>
+      <p:sp>
+        <p:nvSpPr>
+          <p:cNvPr id="13" name="Step 3 heading"/>
+          <p:cNvSpPr txBox="1"/>
+          <p:nvPr/>
+        </p:nvSpPr>
+        <p:spPr>
+          <a:xfrm>
+            <a:off x="8531352" y="1481328"/>
+            <a:ext cx="2926080" cy="365760"/>
+          </a:xfrm>
+          <a:prstGeom prst="rect">
+            <a:avLst/>
+          </a:prstGeom>
+          <a:noFill/>
+          <a:ln/>
+        </p:spPr>
+        <p:txBody>
+          <a:bodyPr wrap="square" lIns="0" tIns="0" rIns="0" bIns="0" rtlCol="0" anchor="t"/>
+          <a:lstStyle/>
+          <a:p>
+            <a:pPr indent="0" marL="0">
+              <a:buNone/>
+            </a:pPr>
+            <a:r>
+              <a:rPr lang="en-US" sz="1400" b="1" dirty="0">
+                <a:solidFill>
+                  <a:schemeClr val="accent1"/>
+                </a:solidFill>
+              </a:rPr>
+              <a:t>Extract provided for this analysis</a:t>
+            </a:r>
+            <a:endParaRPr lang="en-US" sz="1400" dirty="0"/>
+          </a:p>
+        </p:txBody>
+      </p:sp>
+      <p:sp>
+        <p:nvSpPr>
+          <p:cNvPr id="14" name="Step 3 value"/>
+          <p:cNvSpPr txBox="1"/>
+          <p:nvPr/>
+        </p:nvSpPr>
+        <p:spPr>
+          <a:xfrm>
+            <a:off x="8531352" y="1874520"/>
+            <a:ext cx="2926080" cy="640080"/>
+          </a:xfrm>
+          <a:prstGeom prst="rect">
+            <a:avLst/>
+          </a:prstGeom>
+          <a:noFill/>
+          <a:ln/>
+        </p:spPr>
+        <p:txBody>
+          <a:bodyPr wrap="square" lIns="0" tIns="0" rIns="0" bIns="0" rtlCol="0" anchor="ctr"/>
+          <a:lstStyle/>
+          <a:p>
+            <a:pPr indent="0" marL="0">
+              <a:buNone/>
+            </a:pPr>
+            <a:r>
+              <a:rPr lang="en-US" sz="3600" b="1" dirty="0">
+                <a:solidFill>
+                  <a:schemeClr val="tx2"/>
+                </a:solidFill>
+                <a:latin typeface="Cambria" pitchFamily="34" charset="0"/>
+                <a:ea typeface="Cambria" pitchFamily="34" charset="-122"/>
+                <a:cs typeface="Cambria" pitchFamily="34" charset="-120"/>
+              </a:rPr>
+              <a:t>833</a:t>
+            </a:r>
+            <a:endParaRPr lang="en-US" sz="3600" dirty="0"/>
+          </a:p>
+        </p:txBody>
+      </p:sp>
+      <p:sp>
+        <p:nvSpPr>
+          <p:cNvPr id="15" name="Step 3 label"/>
+          <p:cNvSpPr txBox="1"/>
+          <p:nvPr/>
+        </p:nvSpPr>
+        <p:spPr>
+          <a:xfrm>
+            <a:off x="8531352" y="2560320"/>
+            <a:ext cx="2926080" cy="640080"/>
+          </a:xfrm>
+          <a:prstGeom prst="rect">
+            <a:avLst/>
+          </a:prstGeom>
+          <a:noFill/>
+          <a:ln/>
+        </p:spPr>
+        <p:txBody>
+          <a:bodyPr wrap="square" lIns="0" tIns="0" rIns="0" bIns="0" rtlCol="0" anchor="t"/>
+          <a:lstStyle/>
+          <a:p>
+            <a:pPr indent="0" marL="0">
+              <a:buNone/>
+            </a:pPr>
+            <a:r>
+              <a:rPr lang="en-US" sz="1400" dirty="0">
+                <a:solidFill>
+                  <a:schemeClr val="tx1"/>
+                </a:solidFill>
+              </a:rPr>
+              <a:t>company-years (201 firms), simplified to the columns needed</a:t>
+            </a:r>
+            <a:endParaRPr lang="en-US" sz="1400" dirty="0"/>
+          </a:p>
+        </p:txBody>
+      </p:sp>
+      <p:sp>
+        <p:nvSpPr>
+          <p:cNvPr id="16" name="Text 14"/>
+          <p:cNvSpPr txBox="1"/>
+          <p:nvPr/>
+        </p:nvSpPr>
+        <p:spPr>
+          <a:xfrm>
+            <a:off x="548640" y="3566160"/>
+            <a:ext cx="11091672" cy="320040"/>
+          </a:xfrm>
+          <a:prstGeom prst="rect">
+            <a:avLst/>
+          </a:prstGeom>
+          <a:noFill/>
+          <a:ln/>
+        </p:spPr>
+        <p:txBody>
+          <a:bodyPr wrap="square" lIns="0" tIns="0" rIns="0" bIns="0" rtlCol="0" anchor="ctr"/>
+          <a:lstStyle/>
+          <a:p>
+            <a:pPr indent="0" marL="0">
+              <a:buNone/>
+            </a:pPr>
+            <a:r>
+              <a:rPr lang="en-US" sz="1600" b="1" dirty="0">
+                <a:solidFill>
+                  <a:schemeClr val="tx2"/>
+                </a:solidFill>
+              </a:rPr>
+              <a:t>Why it matters</a:t>
+            </a:r>
+            <a:endParaRPr lang="en-US" sz="1600" dirty="0"/>
+          </a:p>
+        </p:txBody>
+      </p:sp>
+      <p:sp>
+        <p:nvSpPr>
+          <p:cNvPr id="17" name="Text 15"/>
+          <p:cNvSpPr txBox="1"/>
+          <p:nvPr/>
+        </p:nvSpPr>
+        <p:spPr>
+          <a:xfrm>
+            <a:off x="548640" y="3931920"/>
+            <a:ext cx="11091672" cy="2377440"/>
+          </a:xfrm>
+          <a:prstGeom prst="rect">
+            <a:avLst/>
+          </a:prstGeom>
+          <a:noFill/>
+          <a:ln/>
+        </p:spPr>
+        <p:txBody>
+          <a:bodyPr wrap="square" lIns="0" tIns="0" rIns="0" bIns="0" rtlCol="0" anchor="t"/>
+          <a:lstStyle/>
+          <a:p>
+            <a:pPr marL="203200" indent="-203200">
+              <a:spcAft>
+                <a:spcPts val="600"/>
+              </a:spcAft>
+              <a:buSzPct val="100000"/>
+              <a:buChar char="•"/>
+            </a:pPr>
+            <a:r>
+              <a:rPr lang="en-US" sz="1500" dirty="0">
+                <a:solidFill>
+                  <a:schemeClr val="tx1"/>
+                </a:solidFill>
+              </a:rPr>
+              <a:t>Zero total debt removed: debt-free firm-years are excluded, which may tilt the sample toward firms that carry debt</a:t>
+            </a:r>
+            <a:endParaRPr lang="en-US" sz="1500" dirty="0"/>
+          </a:p>
+          <a:p>
+            <a:pPr marL="203200" indent="-203200">
+              <a:spcAft>
+                <a:spcPts val="600"/>
+              </a:spcAft>
+              <a:buSzPct val="100000"/>
+              <a:buChar char="•"/>
+            </a:pPr>
+            <a:r>
+              <a:rPr lang="en-US" sz="1500" dirty="0">
+                <a:solidFill>
+                  <a:schemeClr val="tx1"/>
+                </a:solidFill>
+              </a:rPr>
+              <a:t>Blank capex removed: only firm-years that report capital expenditure remain, which may leave out some early-stage or sparse filers</a:t>
+            </a:r>
+            <a:endParaRPr lang="en-US" sz="1500" dirty="0"/>
+          </a:p>
+          <a:p>
+            <a:pPr marL="203200" indent="-203200">
+              <a:spcAft>
+                <a:spcPts val="600"/>
+              </a:spcAft>
+              <a:buSzPct val="100000"/>
+              <a:buChar char="•"/>
+            </a:pPr>
+            <a:r>
+              <a:rPr lang="en-US" sz="1500" dirty="0">
+                <a:solidFill>
+                  <a:schemeClr val="tx1"/>
+                </a:solidFill>
+              </a:rPr>
+              <a:t>These filters were applied before the file reached this analysis, so their effect on the MVE–age correlation has not been measured here; Appendix A2 isolates only the revenue floor (ρ 0.11 → 0.29)</a:t>
+            </a:r>
+            <a:endParaRPr lang="en-US" sz="1500" dirty="0"/>
+          </a:p>
+          <a:p>
+            <a:pPr marL="203200" indent="-203200">
+              <a:spcAft>
+                <a:spcPts val="600"/>
+              </a:spcAft>
+              <a:buSzPct val="100000"/>
+              <a:buChar char="•"/>
+            </a:pPr>
+            <a:r>
+              <a:rPr lang="en-US" sz="1500" dirty="0">
+                <a:solidFill>
+                  <a:schemeClr val="tx1"/>
+                </a:solidFill>
+              </a:rPr>
+              <a:t>To test them, rebuild the charts from the full table with and without each filter</a:t>
+            </a:r>
+            <a:endParaRPr lang="en-US" sz="1500" dirty="0"/>
+          </a:p>
+        </p:txBody>
+      </p:sp>
+      <p:sp>
+        <p:nvSpPr>
+          <p:cNvPr id="25" name="Slide Number Placeholder 0"/>
+          <p:cNvSpPr>
+            <a:spLocks noGrp="1"/>
+          </p:cNvSpPr>
+          <p:nvPr>
+            <p:ph type="sldNum" sz="quarter" idx="4294967295"/>
+          </p:nvPr>
+        </p:nvSpPr>
+        <p:spPr>
+          <a:xfrm>
+            <a:off x="11183112" y="6446520"/>
+            <a:ext cx="457200" cy="274320"/>
+          </a:xfrm>
+          <a:prstGeom prst="rect">
+            <a:avLst/>
+          </a:prstGeom>
+          <a:extLst>
+            <a:ext uri="{C572A759-6A51-4108-AA02-DFA0A04FC94B}">
+              <ma14:wrappingTextBoxFlag xmlns:ma14="http://schemas.microsoft.com/office/mac/drawingml/2011/main" val="0"/>
+            </a:ext>
+          </a:extLst>
+        </p:spPr>
+        <p:txBody>
+          <a:bodyPr/>
+          <a:lstStyle>
+            <a:lvl1pPr>
+              <a:defRPr sz="1000">
+                <a:solidFill>
+                  <a:schemeClr val="accent3"/>
+                </a:solidFill>
+              </a:defRPr>
+            </a:lvl1pPr>
+          </a:lstStyle>
+          <a:p>
+            <a:pPr algn="r"/>
+            <a:fld id="{F7021451-1387-4CA6-816F-3879F97B5CBC}" type="slidenum">
+              <a:rPr b="0" lang="en-US"/>
+              <a:t>7</a:t>
+            </a:fld>
+            <a:endParaRPr lang="en-US"/>
+          </a:p>
+        </p:txBody>
+      </p:sp>
+    </p:spTree>
+  </p:cSld>
+  <p:clrMapOvr>
+    <a:masterClrMapping/>
+  </p:clrMapOvr>
+</p:sld>
+</file>
+
+<file path=ppt/slides/slide8.xml><?xml version="1.0" encoding="utf-8"?>
+<p:sld xmlns:a="http://schemas.openxmlformats.org/drawingml/2006/main" xmlns:r="http://schemas.openxmlformats.org/officeDocument/2006/relationships" xmlns:p="http://schemas.openxmlformats.org/presentationml/2006/main">
+  <p:cSld name="Slide 8">
+    <p:spTree>
+      <p:nvGrpSpPr>
+        <p:cNvPr id="1" name=""/>
+        <p:cNvGrpSpPr/>
+        <p:nvPr/>
+      </p:nvGrpSpPr>
+      <p:grpSpPr>
+        <a:xfrm>
+          <a:off x="0" y="0"/>
+          <a:ext cx="0" cy="0"/>
+          <a:chOff x="0" y="0"/>
+          <a:chExt cx="0" cy="0"/>
+        </a:xfrm>
+      </p:grpSpPr>
+      <p:sp>
+        <p:nvSpPr>
+          <p:cNvPr id="2" name="Text 0"/>
+          <p:cNvSpPr/>
+          <p:nvPr>
+            <p:ph idx="100" type="title" hasCustomPrompt="1"/>
+          </p:nvPr>
+        </p:nvSpPr>
+        <p:spPr>
+          <a:xfrm>
+            <a:off x="548640" y="320040"/>
+            <a:ext cx="11091672" cy="914400"/>
+          </a:xfrm>
+          <a:prstGeom prst="rect">
+            <a:avLst/>
+          </a:prstGeom>
+          <a:noFill/>
+          <a:ln/>
+        </p:spPr>
+        <p:txBody>
+          <a:bodyPr wrap="square" lIns="0" tIns="0" rIns="0" bIns="0" rtlCol="0" anchor="ctr"/>
+          <a:lstStyle/>
+          <a:p>
+            <a:pPr algn="l" indent="0" marL="0">
+              <a:buNone/>
+            </a:pPr>
+            <a:r>
+              <a:rPr lang="en-US" sz="3000" b="1" dirty="0">
+                <a:solidFill>
+                  <a:schemeClr val="tx2"/>
+                </a:solidFill>
+                <a:latin typeface="Cambria" pitchFamily="34" charset="0"/>
+                <a:ea typeface="Cambria" pitchFamily="34" charset="-122"/>
+                <a:cs typeface="Cambria" pitchFamily="34" charset="-120"/>
+              </a:rPr>
+              <a:t>Appendix A2: Data cleaning choices and their effects</a:t>
+            </a:r>
+            <a:endParaRPr lang="en-US" sz="3000" dirty="0"/>
+          </a:p>
+        </p:txBody>
+      </p:sp>
       <p:graphicFrame>
         <p:nvGraphicFramePr>
-          <p:cNvPr id="8" name="Cleaning effects table"/>
+          <p:cNvPr id="9" name="Cleaning effects table"/>
           <p:cNvGraphicFramePr>
             <a:graphicFrameLocks noGrp="1"/>
           </p:cNvGraphicFramePr>
@@ -8245,7 +10579,7 @@
                   <a:schemeClr val="tx1"/>
                 </a:solidFill>
               </a:rPr>
-              <a:t>No firms were dropped for missing data (no missing values in the columns used)</a:t>
+              <a:t>No firms were dropped for missing data in this analysis (no missing values in the columns used); upstream filters are in Appendix A1</a:t>
             </a:r>
             <a:endParaRPr lang="en-US" sz="1400" dirty="0"/>
           </a:p>
@@ -8290,7 +10624,7 @@
             <a:pPr algn="r"/>
             <a:fld id="{F7021451-1387-4CA6-816F-3879F97B5CBC}" type="slidenum">
               <a:rPr b="0" lang="en-US"/>
-              <a:t>7</a:t>
+              <a:t>8</a:t>
             </a:fld>
             <a:endParaRPr lang="en-US"/>
           </a:p>
@@ -8304,9 +10638,9 @@
 </p:sld>
 </file>
 
-<file path=ppt/slides/slide8.xml><?xml version="1.0" encoding="utf-8"?>
+<file path=ppt/slides/slide9.xml><?xml version="1.0" encoding="utf-8"?>
 <p:sld xmlns:a="http://schemas.openxmlformats.org/drawingml/2006/main" xmlns:r="http://schemas.openxmlformats.org/officeDocument/2006/relationships" xmlns:p="http://schemas.openxmlformats.org/presentationml/2006/main">
-  <p:cSld name="Slide 8">
+  <p:cSld name="Slide 9">
     <p:spTree>
       <p:nvGrpSpPr>
         <p:cNvPr id="1" name=""/>
@@ -8356,7 +10690,7 @@
                 <a:ea typeface="Cambria" pitchFamily="34" charset="-122"/>
                 <a:cs typeface="Cambria" pitchFamily="34" charset="-120"/>
               </a:rPr>
-              <a:t>Appendix A2: Robustness checks</a:t>
+              <a:t>Appendix A3: Robustness checks</a:t>
             </a:r>
             <a:endParaRPr lang="en-US" sz="3000" dirty="0"/>
           </a:p>
@@ -8364,7 +10698,7 @@
       </p:sp>
       <p:graphicFrame>
         <p:nvGraphicFramePr>
-          <p:cNvPr id="9" name="Robustness table"/>
+          <p:cNvPr id="10" name="Robustness table"/>
           <p:cNvGraphicFramePr>
             <a:graphicFrameLocks noGrp="1"/>
           </p:cNvGraphicFramePr>
@@ -9998,1544 +12332,6 @@
                 </a:solidFill>
               </a:rPr>
               <a:t>Scale matters more than age: revenue has ρ = 0.76 with MVE (and 0.37 with age)</a:t>
-            </a:r>
-            <a:endParaRPr lang="en-US" sz="1400" dirty="0"/>
-          </a:p>
-        </p:txBody>
-      </p:sp>
-      <p:sp>
-        <p:nvSpPr>
-          <p:cNvPr id="25" name="Slide Number Placeholder 0"/>
-          <p:cNvSpPr>
-            <a:spLocks noGrp="1"/>
-          </p:cNvSpPr>
-          <p:nvPr>
-            <p:ph type="sldNum" sz="quarter" idx="4294967295"/>
-          </p:nvPr>
-        </p:nvSpPr>
-        <p:spPr>
-          <a:xfrm>
-            <a:off x="11183112" y="6446520"/>
-            <a:ext cx="457200" cy="274320"/>
-          </a:xfrm>
-          <a:prstGeom prst="rect">
-            <a:avLst/>
-          </a:prstGeom>
-          <a:extLst>
-            <a:ext uri="{C572A759-6A51-4108-AA02-DFA0A04FC94B}">
-              <ma14:wrappingTextBoxFlag xmlns:ma14="http://schemas.microsoft.com/office/mac/drawingml/2011/main" val="0"/>
-            </a:ext>
-          </a:extLst>
-        </p:spPr>
-        <p:txBody>
-          <a:bodyPr/>
-          <a:lstStyle>
-            <a:lvl1pPr>
-              <a:defRPr sz="1000">
-                <a:solidFill>
-                  <a:schemeClr val="accent3"/>
-                </a:solidFill>
-              </a:defRPr>
-            </a:lvl1pPr>
-          </a:lstStyle>
-          <a:p>
-            <a:pPr algn="r"/>
-            <a:fld id="{F7021451-1387-4CA6-816F-3879F97B5CBC}" type="slidenum">
-              <a:rPr b="0" lang="en-US"/>
-              <a:t>8</a:t>
-            </a:fld>
-            <a:endParaRPr lang="en-US"/>
-          </a:p>
-        </p:txBody>
-      </p:sp>
-    </p:spTree>
-  </p:cSld>
-  <p:clrMapOvr>
-    <a:masterClrMapping/>
-  </p:clrMapOvr>
-</p:sld>
-</file>
-
-<file path=ppt/slides/slide9.xml><?xml version="1.0" encoding="utf-8"?>
-<p:sld xmlns:a="http://schemas.openxmlformats.org/drawingml/2006/main" xmlns:r="http://schemas.openxmlformats.org/officeDocument/2006/relationships" xmlns:p="http://schemas.openxmlformats.org/presentationml/2006/main">
-  <p:cSld name="Slide 9">
-    <p:spTree>
-      <p:nvGrpSpPr>
-        <p:cNvPr id="1" name=""/>
-        <p:cNvGrpSpPr/>
-        <p:nvPr/>
-      </p:nvGrpSpPr>
-      <p:grpSpPr>
-        <a:xfrm>
-          <a:off x="0" y="0"/>
-          <a:ext cx="0" cy="0"/>
-          <a:chOff x="0" y="0"/>
-          <a:chExt cx="0" cy="0"/>
-        </a:xfrm>
-      </p:grpSpPr>
-      <p:sp>
-        <p:nvSpPr>
-          <p:cNvPr id="2" name="Text 0"/>
-          <p:cNvSpPr/>
-          <p:nvPr>
-            <p:ph idx="100" type="title" hasCustomPrompt="1"/>
-          </p:nvPr>
-        </p:nvSpPr>
-        <p:spPr>
-          <a:xfrm>
-            <a:off x="548640" y="320040"/>
-            <a:ext cx="11091672" cy="914400"/>
-          </a:xfrm>
-          <a:prstGeom prst="rect">
-            <a:avLst/>
-          </a:prstGeom>
-          <a:noFill/>
-          <a:ln/>
-        </p:spPr>
-        <p:txBody>
-          <a:bodyPr wrap="square" lIns="0" tIns="0" rIns="0" bIns="0" rtlCol="0" anchor="ctr"/>
-          <a:lstStyle/>
-          <a:p>
-            <a:pPr algn="l" indent="0" marL="0">
-              <a:buNone/>
-            </a:pPr>
-            <a:r>
-              <a:rPr lang="en-US" sz="3000" b="1" dirty="0">
-                <a:solidFill>
-                  <a:schemeClr val="tx2"/>
-                </a:solidFill>
-                <a:latin typeface="Cambria" pitchFamily="34" charset="0"/>
-                <a:ea typeface="Cambria" pitchFamily="34" charset="-122"/>
-                <a:cs typeface="Cambria" pitchFamily="34" charset="-120"/>
-              </a:rPr>
-              <a:t>Appendix A3: Summary statistics and methods</a:t>
-            </a:r>
-            <a:endParaRPr lang="en-US" sz="3000" dirty="0"/>
-          </a:p>
-        </p:txBody>
-      </p:sp>
-      <p:graphicFrame>
-        <p:nvGraphicFramePr>
-          <p:cNvPr id="10" name="Summary statistics table"/>
-          <p:cNvGraphicFramePr>
-            <a:graphicFrameLocks noGrp="1"/>
-          </p:cNvGraphicFramePr>
-          <p:nvPr>
-            <p:extLst>
-              <p:ext uri="{D42A27DB-BD31-4B8C-83A1-F6EECF244321}">
-                <p14:modId xmlns:p14="http://schemas.microsoft.com/office/powerpoint/2010/main" val="1579011935"/>
-              </p:ext>
-            </p:extLst>
-          </p:nvPr>
-        </p:nvGraphicFramePr>
-        <p:xfrm>
-          <a:off x="548640" y="1371600"/>
-          <a:ext cx="6583680" cy="914400"/>
-        </p:xfrm>
-        <a:graphic>
-          <a:graphicData uri="http://schemas.openxmlformats.org/drawingml/2006/table">
-            <a:tbl>
-              <a:tblPr/>
-              <a:tblGrid>
-                <a:gridCol w="2651760"/>
-                <a:gridCol w="822960"/>
-                <a:gridCol w="1005840"/>
-                <a:gridCol w="1005840"/>
-                <a:gridCol w="1097280"/>
-              </a:tblGrid>
-              <a:tr h="384048">
-                <a:tc>
-                  <a:txBody>
-                    <a:bodyPr/>
-                    <a:lstStyle/>
-                    <a:p>
-                      <a:pPr algn="l" indent="0" marL="0">
-                        <a:buNone/>
-                      </a:pPr>
-                      <a:r>
-                        <a:rPr lang="en-US" sz="1300" b="1" dirty="0">
-                          <a:solidFill>
-                            <a:schemeClr val="bg1"/>
-                          </a:solidFill>
-                        </a:rPr>
-                        <a:t>Variable</a:t>
-                      </a:r>
-                      <a:endParaRPr lang="en-US" sz="1300" dirty="0"/>
-                    </a:p>
-                  </a:txBody>
-                  <a:tcPr marL="91440" marR="91440" marT="45720" marB="45720" anchor="ctr">
-                    <a:lnL w="6350" cap="flat" cmpd="sng" algn="ctr">
-                      <a:solidFill>
-                        <a:srgbClr val="D5DDE0"/>
-                      </a:solidFill>
-                      <a:prstDash val="solid"/>
-                      <a:round/>
-                      <a:headEnd type="none" w="med" len="med"/>
-                      <a:tailEnd type="none" w="med" len="med"/>
-                    </a:lnL>
-                    <a:lnR w="6350" cap="flat" cmpd="sng" algn="ctr">
-                      <a:solidFill>
-                        <a:srgbClr val="D5DDE0"/>
-                      </a:solidFill>
-                      <a:prstDash val="solid"/>
-                      <a:round/>
-                      <a:headEnd type="none" w="med" len="med"/>
-                      <a:tailEnd type="none" w="med" len="med"/>
-                    </a:lnR>
-                    <a:lnT w="6350" cap="flat" cmpd="sng" algn="ctr">
-                      <a:solidFill>
-                        <a:srgbClr val="D5DDE0"/>
-                      </a:solidFill>
-                      <a:prstDash val="solid"/>
-                      <a:round/>
-                      <a:headEnd type="none" w="med" len="med"/>
-                      <a:tailEnd type="none" w="med" len="med"/>
-                    </a:lnT>
-                    <a:lnB w="6350" cap="flat" cmpd="sng" algn="ctr">
-                      <a:solidFill>
-                        <a:srgbClr val="D5DDE0"/>
-                      </a:solidFill>
-                      <a:prstDash val="solid"/>
-                      <a:round/>
-                      <a:headEnd type="none" w="med" len="med"/>
-                      <a:tailEnd type="none" w="med" len="med"/>
-                    </a:lnB>
-                    <a:solidFill>
-                      <a:schemeClr val="tx2"/>
-                    </a:solidFill>
-                  </a:tcPr>
-                </a:tc>
-                <a:tc>
-                  <a:txBody>
-                    <a:bodyPr/>
-                    <a:lstStyle/>
-                    <a:p>
-                      <a:pPr algn="r" indent="0" marL="0">
-                        <a:buNone/>
-                      </a:pPr>
-                      <a:r>
-                        <a:rPr lang="en-US" sz="1300" b="1" dirty="0">
-                          <a:solidFill>
-                            <a:schemeClr val="bg1"/>
-                          </a:solidFill>
-                        </a:rPr>
-                        <a:t>Min</a:t>
-                      </a:r>
-                      <a:endParaRPr lang="en-US" sz="1300" dirty="0"/>
-                    </a:p>
-                  </a:txBody>
-                  <a:tcPr marL="91440" marR="91440" marT="45720" marB="45720" anchor="ctr">
-                    <a:lnL w="6350" cap="flat" cmpd="sng" algn="ctr">
-                      <a:solidFill>
-                        <a:srgbClr val="D5DDE0"/>
-                      </a:solidFill>
-                      <a:prstDash val="solid"/>
-                      <a:round/>
-                      <a:headEnd type="none" w="med" len="med"/>
-                      <a:tailEnd type="none" w="med" len="med"/>
-                    </a:lnL>
-                    <a:lnR w="6350" cap="flat" cmpd="sng" algn="ctr">
-                      <a:solidFill>
-                        <a:srgbClr val="D5DDE0"/>
-                      </a:solidFill>
-                      <a:prstDash val="solid"/>
-                      <a:round/>
-                      <a:headEnd type="none" w="med" len="med"/>
-                      <a:tailEnd type="none" w="med" len="med"/>
-                    </a:lnR>
-                    <a:lnT w="6350" cap="flat" cmpd="sng" algn="ctr">
-                      <a:solidFill>
-                        <a:srgbClr val="D5DDE0"/>
-                      </a:solidFill>
-                      <a:prstDash val="solid"/>
-                      <a:round/>
-                      <a:headEnd type="none" w="med" len="med"/>
-                      <a:tailEnd type="none" w="med" len="med"/>
-                    </a:lnT>
-                    <a:lnB w="6350" cap="flat" cmpd="sng" algn="ctr">
-                      <a:solidFill>
-                        <a:srgbClr val="D5DDE0"/>
-                      </a:solidFill>
-                      <a:prstDash val="solid"/>
-                      <a:round/>
-                      <a:headEnd type="none" w="med" len="med"/>
-                      <a:tailEnd type="none" w="med" len="med"/>
-                    </a:lnB>
-                    <a:solidFill>
-                      <a:schemeClr val="tx2"/>
-                    </a:solidFill>
-                  </a:tcPr>
-                </a:tc>
-                <a:tc>
-                  <a:txBody>
-                    <a:bodyPr/>
-                    <a:lstStyle/>
-                    <a:p>
-                      <a:pPr algn="r" indent="0" marL="0">
-                        <a:buNone/>
-                      </a:pPr>
-                      <a:r>
-                        <a:rPr lang="en-US" sz="1300" b="1" dirty="0">
-                          <a:solidFill>
-                            <a:schemeClr val="bg1"/>
-                          </a:solidFill>
-                        </a:rPr>
-                        <a:t>Median</a:t>
-                      </a:r>
-                      <a:endParaRPr lang="en-US" sz="1300" dirty="0"/>
-                    </a:p>
-                  </a:txBody>
-                  <a:tcPr marL="91440" marR="91440" marT="45720" marB="45720" anchor="ctr">
-                    <a:lnL w="6350" cap="flat" cmpd="sng" algn="ctr">
-                      <a:solidFill>
-                        <a:srgbClr val="D5DDE0"/>
-                      </a:solidFill>
-                      <a:prstDash val="solid"/>
-                      <a:round/>
-                      <a:headEnd type="none" w="med" len="med"/>
-                      <a:tailEnd type="none" w="med" len="med"/>
-                    </a:lnL>
-                    <a:lnR w="6350" cap="flat" cmpd="sng" algn="ctr">
-                      <a:solidFill>
-                        <a:srgbClr val="D5DDE0"/>
-                      </a:solidFill>
-                      <a:prstDash val="solid"/>
-                      <a:round/>
-                      <a:headEnd type="none" w="med" len="med"/>
-                      <a:tailEnd type="none" w="med" len="med"/>
-                    </a:lnR>
-                    <a:lnT w="6350" cap="flat" cmpd="sng" algn="ctr">
-                      <a:solidFill>
-                        <a:srgbClr val="D5DDE0"/>
-                      </a:solidFill>
-                      <a:prstDash val="solid"/>
-                      <a:round/>
-                      <a:headEnd type="none" w="med" len="med"/>
-                      <a:tailEnd type="none" w="med" len="med"/>
-                    </a:lnT>
-                    <a:lnB w="6350" cap="flat" cmpd="sng" algn="ctr">
-                      <a:solidFill>
-                        <a:srgbClr val="D5DDE0"/>
-                      </a:solidFill>
-                      <a:prstDash val="solid"/>
-                      <a:round/>
-                      <a:headEnd type="none" w="med" len="med"/>
-                      <a:tailEnd type="none" w="med" len="med"/>
-                    </a:lnB>
-                    <a:solidFill>
-                      <a:schemeClr val="tx2"/>
-                    </a:solidFill>
-                  </a:tcPr>
-                </a:tc>
-                <a:tc>
-                  <a:txBody>
-                    <a:bodyPr/>
-                    <a:lstStyle/>
-                    <a:p>
-                      <a:pPr algn="r" indent="0" marL="0">
-                        <a:buNone/>
-                      </a:pPr>
-                      <a:r>
-                        <a:rPr lang="en-US" sz="1300" b="1" dirty="0">
-                          <a:solidFill>
-                            <a:schemeClr val="bg1"/>
-                          </a:solidFill>
-                        </a:rPr>
-                        <a:t>Mean</a:t>
-                      </a:r>
-                      <a:endParaRPr lang="en-US" sz="1300" dirty="0"/>
-                    </a:p>
-                  </a:txBody>
-                  <a:tcPr marL="91440" marR="91440" marT="45720" marB="45720" anchor="ctr">
-                    <a:lnL w="6350" cap="flat" cmpd="sng" algn="ctr">
-                      <a:solidFill>
-                        <a:srgbClr val="D5DDE0"/>
-                      </a:solidFill>
-                      <a:prstDash val="solid"/>
-                      <a:round/>
-                      <a:headEnd type="none" w="med" len="med"/>
-                      <a:tailEnd type="none" w="med" len="med"/>
-                    </a:lnL>
-                    <a:lnR w="6350" cap="flat" cmpd="sng" algn="ctr">
-                      <a:solidFill>
-                        <a:srgbClr val="D5DDE0"/>
-                      </a:solidFill>
-                      <a:prstDash val="solid"/>
-                      <a:round/>
-                      <a:headEnd type="none" w="med" len="med"/>
-                      <a:tailEnd type="none" w="med" len="med"/>
-                    </a:lnR>
-                    <a:lnT w="6350" cap="flat" cmpd="sng" algn="ctr">
-                      <a:solidFill>
-                        <a:srgbClr val="D5DDE0"/>
-                      </a:solidFill>
-                      <a:prstDash val="solid"/>
-                      <a:round/>
-                      <a:headEnd type="none" w="med" len="med"/>
-                      <a:tailEnd type="none" w="med" len="med"/>
-                    </a:lnT>
-                    <a:lnB w="6350" cap="flat" cmpd="sng" algn="ctr">
-                      <a:solidFill>
-                        <a:srgbClr val="D5DDE0"/>
-                      </a:solidFill>
-                      <a:prstDash val="solid"/>
-                      <a:round/>
-                      <a:headEnd type="none" w="med" len="med"/>
-                      <a:tailEnd type="none" w="med" len="med"/>
-                    </a:lnB>
-                    <a:solidFill>
-                      <a:schemeClr val="tx2"/>
-                    </a:solidFill>
-                  </a:tcPr>
-                </a:tc>
-                <a:tc>
-                  <a:txBody>
-                    <a:bodyPr/>
-                    <a:lstStyle/>
-                    <a:p>
-                      <a:pPr algn="r" indent="0" marL="0">
-                        <a:buNone/>
-                      </a:pPr>
-                      <a:r>
-                        <a:rPr lang="en-US" sz="1300" b="1" dirty="0">
-                          <a:solidFill>
-                            <a:schemeClr val="bg1"/>
-                          </a:solidFill>
-                        </a:rPr>
-                        <a:t>Max</a:t>
-                      </a:r>
-                      <a:endParaRPr lang="en-US" sz="1300" dirty="0"/>
-                    </a:p>
-                  </a:txBody>
-                  <a:tcPr marL="91440" marR="91440" marT="45720" marB="45720" anchor="ctr">
-                    <a:lnL w="6350" cap="flat" cmpd="sng" algn="ctr">
-                      <a:solidFill>
-                        <a:srgbClr val="D5DDE0"/>
-                      </a:solidFill>
-                      <a:prstDash val="solid"/>
-                      <a:round/>
-                      <a:headEnd type="none" w="med" len="med"/>
-                      <a:tailEnd type="none" w="med" len="med"/>
-                    </a:lnL>
-                    <a:lnR w="6350" cap="flat" cmpd="sng" algn="ctr">
-                      <a:solidFill>
-                        <a:srgbClr val="D5DDE0"/>
-                      </a:solidFill>
-                      <a:prstDash val="solid"/>
-                      <a:round/>
-                      <a:headEnd type="none" w="med" len="med"/>
-                      <a:tailEnd type="none" w="med" len="med"/>
-                    </a:lnR>
-                    <a:lnT w="6350" cap="flat" cmpd="sng" algn="ctr">
-                      <a:solidFill>
-                        <a:srgbClr val="D5DDE0"/>
-                      </a:solidFill>
-                      <a:prstDash val="solid"/>
-                      <a:round/>
-                      <a:headEnd type="none" w="med" len="med"/>
-                      <a:tailEnd type="none" w="med" len="med"/>
-                    </a:lnT>
-                    <a:lnB w="6350" cap="flat" cmpd="sng" algn="ctr">
-                      <a:solidFill>
-                        <a:srgbClr val="D5DDE0"/>
-                      </a:solidFill>
-                      <a:prstDash val="solid"/>
-                      <a:round/>
-                      <a:headEnd type="none" w="med" len="med"/>
-                      <a:tailEnd type="none" w="med" len="med"/>
-                    </a:lnB>
-                    <a:solidFill>
-                      <a:schemeClr val="tx2"/>
-                    </a:solidFill>
-                  </a:tcPr>
-                </a:tc>
-              </a:tr>
-              <a:tr h="384048">
-                <a:tc>
-                  <a:txBody>
-                    <a:bodyPr/>
-                    <a:lstStyle/>
-                    <a:p>
-                      <a:pPr indent="0" marL="0">
-                        <a:buNone/>
-                      </a:pPr>
-                      <a:r>
-                        <a:rPr lang="en-US" sz="1300" dirty="0">
-                          <a:solidFill>
-                            <a:schemeClr val="tx1"/>
-                          </a:solidFill>
-                        </a:rPr>
-                        <a:t>MVE ($ millions)</a:t>
-                      </a:r>
-                      <a:endParaRPr lang="en-US" sz="1300" dirty="0"/>
-                    </a:p>
-                  </a:txBody>
-                  <a:tcPr marL="91440" marR="91440" marT="45720" marB="45720" anchor="ctr">
-                    <a:lnL w="6350" cap="flat" cmpd="sng" algn="ctr">
-                      <a:solidFill>
-                        <a:srgbClr val="D5DDE0"/>
-                      </a:solidFill>
-                      <a:prstDash val="solid"/>
-                      <a:round/>
-                      <a:headEnd type="none" w="med" len="med"/>
-                      <a:tailEnd type="none" w="med" len="med"/>
-                    </a:lnL>
-                    <a:lnR w="6350" cap="flat" cmpd="sng" algn="ctr">
-                      <a:solidFill>
-                        <a:srgbClr val="D5DDE0"/>
-                      </a:solidFill>
-                      <a:prstDash val="solid"/>
-                      <a:round/>
-                      <a:headEnd type="none" w="med" len="med"/>
-                      <a:tailEnd type="none" w="med" len="med"/>
-                    </a:lnR>
-                    <a:lnT w="6350" cap="flat" cmpd="sng" algn="ctr">
-                      <a:solidFill>
-                        <a:srgbClr val="D5DDE0"/>
-                      </a:solidFill>
-                      <a:prstDash val="solid"/>
-                      <a:round/>
-                      <a:headEnd type="none" w="med" len="med"/>
-                      <a:tailEnd type="none" w="med" len="med"/>
-                    </a:lnT>
-                    <a:lnB w="6350" cap="flat" cmpd="sng" algn="ctr">
-                      <a:solidFill>
-                        <a:srgbClr val="D5DDE0"/>
-                      </a:solidFill>
-                      <a:prstDash val="solid"/>
-                      <a:round/>
-                      <a:headEnd type="none" w="med" len="med"/>
-                      <a:tailEnd type="none" w="med" len="med"/>
-                    </a:lnB>
-                    <a:solidFill>
-                      <a:srgbClr val="FFFFFF"/>
-                    </a:solidFill>
-                  </a:tcPr>
-                </a:tc>
-                <a:tc>
-                  <a:txBody>
-                    <a:bodyPr/>
-                    <a:lstStyle/>
-                    <a:p>
-                      <a:pPr algn="r" indent="0" marL="0">
-                        <a:buNone/>
-                      </a:pPr>
-                      <a:r>
-                        <a:rPr lang="en-US" sz="1300" dirty="0">
-                          <a:solidFill>
-                            <a:schemeClr val="tx1"/>
-                          </a:solidFill>
-                        </a:rPr>
-                        <a:t>16</a:t>
-                      </a:r>
-                      <a:endParaRPr lang="en-US" sz="1300" dirty="0"/>
-                    </a:p>
-                  </a:txBody>
-                  <a:tcPr marL="91440" marR="91440" marT="45720" marB="45720" anchor="ctr">
-                    <a:lnL w="6350" cap="flat" cmpd="sng" algn="ctr">
-                      <a:solidFill>
-                        <a:srgbClr val="D5DDE0"/>
-                      </a:solidFill>
-                      <a:prstDash val="solid"/>
-                      <a:round/>
-                      <a:headEnd type="none" w="med" len="med"/>
-                      <a:tailEnd type="none" w="med" len="med"/>
-                    </a:lnL>
-                    <a:lnR w="6350" cap="flat" cmpd="sng" algn="ctr">
-                      <a:solidFill>
-                        <a:srgbClr val="D5DDE0"/>
-                      </a:solidFill>
-                      <a:prstDash val="solid"/>
-                      <a:round/>
-                      <a:headEnd type="none" w="med" len="med"/>
-                      <a:tailEnd type="none" w="med" len="med"/>
-                    </a:lnR>
-                    <a:lnT w="6350" cap="flat" cmpd="sng" algn="ctr">
-                      <a:solidFill>
-                        <a:srgbClr val="D5DDE0"/>
-                      </a:solidFill>
-                      <a:prstDash val="solid"/>
-                      <a:round/>
-                      <a:headEnd type="none" w="med" len="med"/>
-                      <a:tailEnd type="none" w="med" len="med"/>
-                    </a:lnT>
-                    <a:lnB w="6350" cap="flat" cmpd="sng" algn="ctr">
-                      <a:solidFill>
-                        <a:srgbClr val="D5DDE0"/>
-                      </a:solidFill>
-                      <a:prstDash val="solid"/>
-                      <a:round/>
-                      <a:headEnd type="none" w="med" len="med"/>
-                      <a:tailEnd type="none" w="med" len="med"/>
-                    </a:lnB>
-                    <a:solidFill>
-                      <a:srgbClr val="FFFFFF"/>
-                    </a:solidFill>
-                  </a:tcPr>
-                </a:tc>
-                <a:tc>
-                  <a:txBody>
-                    <a:bodyPr/>
-                    <a:lstStyle/>
-                    <a:p>
-                      <a:pPr algn="r" indent="0" marL="0">
-                        <a:buNone/>
-                      </a:pPr>
-                      <a:r>
-                        <a:rPr lang="en-US" sz="1300" dirty="0">
-                          <a:solidFill>
-                            <a:schemeClr val="tx1"/>
-                          </a:solidFill>
-                        </a:rPr>
-                        <a:t>2,560</a:t>
-                      </a:r>
-                      <a:endParaRPr lang="en-US" sz="1300" dirty="0"/>
-                    </a:p>
-                  </a:txBody>
-                  <a:tcPr marL="91440" marR="91440" marT="45720" marB="45720" anchor="ctr">
-                    <a:lnL w="6350" cap="flat" cmpd="sng" algn="ctr">
-                      <a:solidFill>
-                        <a:srgbClr val="D5DDE0"/>
-                      </a:solidFill>
-                      <a:prstDash val="solid"/>
-                      <a:round/>
-                      <a:headEnd type="none" w="med" len="med"/>
-                      <a:tailEnd type="none" w="med" len="med"/>
-                    </a:lnL>
-                    <a:lnR w="6350" cap="flat" cmpd="sng" algn="ctr">
-                      <a:solidFill>
-                        <a:srgbClr val="D5DDE0"/>
-                      </a:solidFill>
-                      <a:prstDash val="solid"/>
-                      <a:round/>
-                      <a:headEnd type="none" w="med" len="med"/>
-                      <a:tailEnd type="none" w="med" len="med"/>
-                    </a:lnR>
-                    <a:lnT w="6350" cap="flat" cmpd="sng" algn="ctr">
-                      <a:solidFill>
-                        <a:srgbClr val="D5DDE0"/>
-                      </a:solidFill>
-                      <a:prstDash val="solid"/>
-                      <a:round/>
-                      <a:headEnd type="none" w="med" len="med"/>
-                      <a:tailEnd type="none" w="med" len="med"/>
-                    </a:lnT>
-                    <a:lnB w="6350" cap="flat" cmpd="sng" algn="ctr">
-                      <a:solidFill>
-                        <a:srgbClr val="D5DDE0"/>
-                      </a:solidFill>
-                      <a:prstDash val="solid"/>
-                      <a:round/>
-                      <a:headEnd type="none" w="med" len="med"/>
-                      <a:tailEnd type="none" w="med" len="med"/>
-                    </a:lnB>
-                    <a:solidFill>
-                      <a:srgbClr val="FFFFFF"/>
-                    </a:solidFill>
-                  </a:tcPr>
-                </a:tc>
-                <a:tc>
-                  <a:txBody>
-                    <a:bodyPr/>
-                    <a:lstStyle/>
-                    <a:p>
-                      <a:pPr algn="r" indent="0" marL="0">
-                        <a:buNone/>
-                      </a:pPr>
-                      <a:r>
-                        <a:rPr lang="en-US" sz="1300" dirty="0">
-                          <a:solidFill>
-                            <a:schemeClr val="tx1"/>
-                          </a:solidFill>
-                        </a:rPr>
-                        <a:t>13,583</a:t>
-                      </a:r>
-                      <a:endParaRPr lang="en-US" sz="1300" dirty="0"/>
-                    </a:p>
-                  </a:txBody>
-                  <a:tcPr marL="91440" marR="91440" marT="45720" marB="45720" anchor="ctr">
-                    <a:lnL w="6350" cap="flat" cmpd="sng" algn="ctr">
-                      <a:solidFill>
-                        <a:srgbClr val="D5DDE0"/>
-                      </a:solidFill>
-                      <a:prstDash val="solid"/>
-                      <a:round/>
-                      <a:headEnd type="none" w="med" len="med"/>
-                      <a:tailEnd type="none" w="med" len="med"/>
-                    </a:lnL>
-                    <a:lnR w="6350" cap="flat" cmpd="sng" algn="ctr">
-                      <a:solidFill>
-                        <a:srgbClr val="D5DDE0"/>
-                      </a:solidFill>
-                      <a:prstDash val="solid"/>
-                      <a:round/>
-                      <a:headEnd type="none" w="med" len="med"/>
-                      <a:tailEnd type="none" w="med" len="med"/>
-                    </a:lnR>
-                    <a:lnT w="6350" cap="flat" cmpd="sng" algn="ctr">
-                      <a:solidFill>
-                        <a:srgbClr val="D5DDE0"/>
-                      </a:solidFill>
-                      <a:prstDash val="solid"/>
-                      <a:round/>
-                      <a:headEnd type="none" w="med" len="med"/>
-                      <a:tailEnd type="none" w="med" len="med"/>
-                    </a:lnT>
-                    <a:lnB w="6350" cap="flat" cmpd="sng" algn="ctr">
-                      <a:solidFill>
-                        <a:srgbClr val="D5DDE0"/>
-                      </a:solidFill>
-                      <a:prstDash val="solid"/>
-                      <a:round/>
-                      <a:headEnd type="none" w="med" len="med"/>
-                      <a:tailEnd type="none" w="med" len="med"/>
-                    </a:lnB>
-                    <a:solidFill>
-                      <a:srgbClr val="FFFFFF"/>
-                    </a:solidFill>
-                  </a:tcPr>
-                </a:tc>
-                <a:tc>
-                  <a:txBody>
-                    <a:bodyPr/>
-                    <a:lstStyle/>
-                    <a:p>
-                      <a:pPr algn="r" indent="0" marL="0">
-                        <a:buNone/>
-                      </a:pPr>
-                      <a:r>
-                        <a:rPr lang="en-US" sz="1300" dirty="0">
-                          <a:solidFill>
-                            <a:schemeClr val="tx1"/>
-                          </a:solidFill>
-                        </a:rPr>
-                        <a:t>313,686</a:t>
-                      </a:r>
-                      <a:endParaRPr lang="en-US" sz="1300" dirty="0"/>
-                    </a:p>
-                  </a:txBody>
-                  <a:tcPr marL="91440" marR="91440" marT="45720" marB="45720" anchor="ctr">
-                    <a:lnL w="6350" cap="flat" cmpd="sng" algn="ctr">
-                      <a:solidFill>
-                        <a:srgbClr val="D5DDE0"/>
-                      </a:solidFill>
-                      <a:prstDash val="solid"/>
-                      <a:round/>
-                      <a:headEnd type="none" w="med" len="med"/>
-                      <a:tailEnd type="none" w="med" len="med"/>
-                    </a:lnL>
-                    <a:lnR w="6350" cap="flat" cmpd="sng" algn="ctr">
-                      <a:solidFill>
-                        <a:srgbClr val="D5DDE0"/>
-                      </a:solidFill>
-                      <a:prstDash val="solid"/>
-                      <a:round/>
-                      <a:headEnd type="none" w="med" len="med"/>
-                      <a:tailEnd type="none" w="med" len="med"/>
-                    </a:lnR>
-                    <a:lnT w="6350" cap="flat" cmpd="sng" algn="ctr">
-                      <a:solidFill>
-                        <a:srgbClr val="D5DDE0"/>
-                      </a:solidFill>
-                      <a:prstDash val="solid"/>
-                      <a:round/>
-                      <a:headEnd type="none" w="med" len="med"/>
-                      <a:tailEnd type="none" w="med" len="med"/>
-                    </a:lnT>
-                    <a:lnB w="6350" cap="flat" cmpd="sng" algn="ctr">
-                      <a:solidFill>
-                        <a:srgbClr val="D5DDE0"/>
-                      </a:solidFill>
-                      <a:prstDash val="solid"/>
-                      <a:round/>
-                      <a:headEnd type="none" w="med" len="med"/>
-                      <a:tailEnd type="none" w="med" len="med"/>
-                    </a:lnB>
-                    <a:solidFill>
-                      <a:srgbClr val="FFFFFF"/>
-                    </a:solidFill>
-                  </a:tcPr>
-                </a:tc>
-              </a:tr>
-              <a:tr h="384048">
-                <a:tc>
-                  <a:txBody>
-                    <a:bodyPr/>
-                    <a:lstStyle/>
-                    <a:p>
-                      <a:pPr indent="0" marL="0">
-                        <a:buNone/>
-                      </a:pPr>
-                      <a:r>
-                        <a:rPr lang="en-US" sz="1300" dirty="0">
-                          <a:solidFill>
-                            <a:schemeClr val="tx1"/>
-                          </a:solidFill>
-                        </a:rPr>
-                        <a:t>Age (years since first 10-K)</a:t>
-                      </a:r>
-                      <a:endParaRPr lang="en-US" sz="1300" dirty="0"/>
-                    </a:p>
-                  </a:txBody>
-                  <a:tcPr marL="91440" marR="91440" marT="45720" marB="45720" anchor="ctr">
-                    <a:lnL w="6350" cap="flat" cmpd="sng" algn="ctr">
-                      <a:solidFill>
-                        <a:srgbClr val="D5DDE0"/>
-                      </a:solidFill>
-                      <a:prstDash val="solid"/>
-                      <a:round/>
-                      <a:headEnd type="none" w="med" len="med"/>
-                      <a:tailEnd type="none" w="med" len="med"/>
-                    </a:lnL>
-                    <a:lnR w="6350" cap="flat" cmpd="sng" algn="ctr">
-                      <a:solidFill>
-                        <a:srgbClr val="D5DDE0"/>
-                      </a:solidFill>
-                      <a:prstDash val="solid"/>
-                      <a:round/>
-                      <a:headEnd type="none" w="med" len="med"/>
-                      <a:tailEnd type="none" w="med" len="med"/>
-                    </a:lnR>
-                    <a:lnT w="6350" cap="flat" cmpd="sng" algn="ctr">
-                      <a:solidFill>
-                        <a:srgbClr val="D5DDE0"/>
-                      </a:solidFill>
-                      <a:prstDash val="solid"/>
-                      <a:round/>
-                      <a:headEnd type="none" w="med" len="med"/>
-                      <a:tailEnd type="none" w="med" len="med"/>
-                    </a:lnT>
-                    <a:lnB w="6350" cap="flat" cmpd="sng" algn="ctr">
-                      <a:solidFill>
-                        <a:srgbClr val="D5DDE0"/>
-                      </a:solidFill>
-                      <a:prstDash val="solid"/>
-                      <a:round/>
-                      <a:headEnd type="none" w="med" len="med"/>
-                      <a:tailEnd type="none" w="med" len="med"/>
-                    </a:lnB>
-                    <a:solidFill>
-                      <a:srgbClr val="FFFFFF"/>
-                    </a:solidFill>
-                  </a:tcPr>
-                </a:tc>
-                <a:tc>
-                  <a:txBody>
-                    <a:bodyPr/>
-                    <a:lstStyle/>
-                    <a:p>
-                      <a:pPr algn="r" indent="0" marL="0">
-                        <a:buNone/>
-                      </a:pPr>
-                      <a:r>
-                        <a:rPr lang="en-US" sz="1300" dirty="0">
-                          <a:solidFill>
-                            <a:schemeClr val="tx1"/>
-                          </a:solidFill>
-                        </a:rPr>
-                        <a:t>1.0</a:t>
-                      </a:r>
-                      <a:endParaRPr lang="en-US" sz="1300" dirty="0"/>
-                    </a:p>
-                  </a:txBody>
-                  <a:tcPr marL="91440" marR="91440" marT="45720" marB="45720" anchor="ctr">
-                    <a:lnL w="6350" cap="flat" cmpd="sng" algn="ctr">
-                      <a:solidFill>
-                        <a:srgbClr val="D5DDE0"/>
-                      </a:solidFill>
-                      <a:prstDash val="solid"/>
-                      <a:round/>
-                      <a:headEnd type="none" w="med" len="med"/>
-                      <a:tailEnd type="none" w="med" len="med"/>
-                    </a:lnL>
-                    <a:lnR w="6350" cap="flat" cmpd="sng" algn="ctr">
-                      <a:solidFill>
-                        <a:srgbClr val="D5DDE0"/>
-                      </a:solidFill>
-                      <a:prstDash val="solid"/>
-                      <a:round/>
-                      <a:headEnd type="none" w="med" len="med"/>
-                      <a:tailEnd type="none" w="med" len="med"/>
-                    </a:lnR>
-                    <a:lnT w="6350" cap="flat" cmpd="sng" algn="ctr">
-                      <a:solidFill>
-                        <a:srgbClr val="D5DDE0"/>
-                      </a:solidFill>
-                      <a:prstDash val="solid"/>
-                      <a:round/>
-                      <a:headEnd type="none" w="med" len="med"/>
-                      <a:tailEnd type="none" w="med" len="med"/>
-                    </a:lnT>
-                    <a:lnB w="6350" cap="flat" cmpd="sng" algn="ctr">
-                      <a:solidFill>
-                        <a:srgbClr val="D5DDE0"/>
-                      </a:solidFill>
-                      <a:prstDash val="solid"/>
-                      <a:round/>
-                      <a:headEnd type="none" w="med" len="med"/>
-                      <a:tailEnd type="none" w="med" len="med"/>
-                    </a:lnB>
-                    <a:solidFill>
-                      <a:srgbClr val="FFFFFF"/>
-                    </a:solidFill>
-                  </a:tcPr>
-                </a:tc>
-                <a:tc>
-                  <a:txBody>
-                    <a:bodyPr/>
-                    <a:lstStyle/>
-                    <a:p>
-                      <a:pPr algn="r" indent="0" marL="0">
-                        <a:buNone/>
-                      </a:pPr>
-                      <a:r>
-                        <a:rPr lang="en-US" sz="1300" dirty="0">
-                          <a:solidFill>
-                            <a:schemeClr val="tx1"/>
-                          </a:solidFill>
-                        </a:rPr>
-                        <a:t>15.0</a:t>
-                      </a:r>
-                      <a:endParaRPr lang="en-US" sz="1300" dirty="0"/>
-                    </a:p>
-                  </a:txBody>
-                  <a:tcPr marL="91440" marR="91440" marT="45720" marB="45720" anchor="ctr">
-                    <a:lnL w="6350" cap="flat" cmpd="sng" algn="ctr">
-                      <a:solidFill>
-                        <a:srgbClr val="D5DDE0"/>
-                      </a:solidFill>
-                      <a:prstDash val="solid"/>
-                      <a:round/>
-                      <a:headEnd type="none" w="med" len="med"/>
-                      <a:tailEnd type="none" w="med" len="med"/>
-                    </a:lnL>
-                    <a:lnR w="6350" cap="flat" cmpd="sng" algn="ctr">
-                      <a:solidFill>
-                        <a:srgbClr val="D5DDE0"/>
-                      </a:solidFill>
-                      <a:prstDash val="solid"/>
-                      <a:round/>
-                      <a:headEnd type="none" w="med" len="med"/>
-                      <a:tailEnd type="none" w="med" len="med"/>
-                    </a:lnR>
-                    <a:lnT w="6350" cap="flat" cmpd="sng" algn="ctr">
-                      <a:solidFill>
-                        <a:srgbClr val="D5DDE0"/>
-                      </a:solidFill>
-                      <a:prstDash val="solid"/>
-                      <a:round/>
-                      <a:headEnd type="none" w="med" len="med"/>
-                      <a:tailEnd type="none" w="med" len="med"/>
-                    </a:lnT>
-                    <a:lnB w="6350" cap="flat" cmpd="sng" algn="ctr">
-                      <a:solidFill>
-                        <a:srgbClr val="D5DDE0"/>
-                      </a:solidFill>
-                      <a:prstDash val="solid"/>
-                      <a:round/>
-                      <a:headEnd type="none" w="med" len="med"/>
-                      <a:tailEnd type="none" w="med" len="med"/>
-                    </a:lnB>
-                    <a:solidFill>
-                      <a:srgbClr val="FFFFFF"/>
-                    </a:solidFill>
-                  </a:tcPr>
-                </a:tc>
-                <a:tc>
-                  <a:txBody>
-                    <a:bodyPr/>
-                    <a:lstStyle/>
-                    <a:p>
-                      <a:pPr algn="r" indent="0" marL="0">
-                        <a:buNone/>
-                      </a:pPr>
-                      <a:r>
-                        <a:rPr lang="en-US" sz="1300" dirty="0">
-                          <a:solidFill>
-                            <a:schemeClr val="tx1"/>
-                          </a:solidFill>
-                        </a:rPr>
-                        <a:t>16.2</a:t>
-                      </a:r>
-                      <a:endParaRPr lang="en-US" sz="1300" dirty="0"/>
-                    </a:p>
-                  </a:txBody>
-                  <a:tcPr marL="91440" marR="91440" marT="45720" marB="45720" anchor="ctr">
-                    <a:lnL w="6350" cap="flat" cmpd="sng" algn="ctr">
-                      <a:solidFill>
-                        <a:srgbClr val="D5DDE0"/>
-                      </a:solidFill>
-                      <a:prstDash val="solid"/>
-                      <a:round/>
-                      <a:headEnd type="none" w="med" len="med"/>
-                      <a:tailEnd type="none" w="med" len="med"/>
-                    </a:lnL>
-                    <a:lnR w="6350" cap="flat" cmpd="sng" algn="ctr">
-                      <a:solidFill>
-                        <a:srgbClr val="D5DDE0"/>
-                      </a:solidFill>
-                      <a:prstDash val="solid"/>
-                      <a:round/>
-                      <a:headEnd type="none" w="med" len="med"/>
-                      <a:tailEnd type="none" w="med" len="med"/>
-                    </a:lnR>
-                    <a:lnT w="6350" cap="flat" cmpd="sng" algn="ctr">
-                      <a:solidFill>
-                        <a:srgbClr val="D5DDE0"/>
-                      </a:solidFill>
-                      <a:prstDash val="solid"/>
-                      <a:round/>
-                      <a:headEnd type="none" w="med" len="med"/>
-                      <a:tailEnd type="none" w="med" len="med"/>
-                    </a:lnT>
-                    <a:lnB w="6350" cap="flat" cmpd="sng" algn="ctr">
-                      <a:solidFill>
-                        <a:srgbClr val="D5DDE0"/>
-                      </a:solidFill>
-                      <a:prstDash val="solid"/>
-                      <a:round/>
-                      <a:headEnd type="none" w="med" len="med"/>
-                      <a:tailEnd type="none" w="med" len="med"/>
-                    </a:lnB>
-                    <a:solidFill>
-                      <a:srgbClr val="FFFFFF"/>
-                    </a:solidFill>
-                  </a:tcPr>
-                </a:tc>
-                <a:tc>
-                  <a:txBody>
-                    <a:bodyPr/>
-                    <a:lstStyle/>
-                    <a:p>
-                      <a:pPr algn="r" indent="0" marL="0">
-                        <a:buNone/>
-                      </a:pPr>
-                      <a:r>
-                        <a:rPr lang="en-US" sz="1300" dirty="0">
-                          <a:solidFill>
-                            <a:schemeClr val="tx1"/>
-                          </a:solidFill>
-                        </a:rPr>
-                        <a:t>41.8</a:t>
-                      </a:r>
-                      <a:endParaRPr lang="en-US" sz="1300" dirty="0"/>
-                    </a:p>
-                  </a:txBody>
-                  <a:tcPr marL="91440" marR="91440" marT="45720" marB="45720" anchor="ctr">
-                    <a:lnL w="6350" cap="flat" cmpd="sng" algn="ctr">
-                      <a:solidFill>
-                        <a:srgbClr val="D5DDE0"/>
-                      </a:solidFill>
-                      <a:prstDash val="solid"/>
-                      <a:round/>
-                      <a:headEnd type="none" w="med" len="med"/>
-                      <a:tailEnd type="none" w="med" len="med"/>
-                    </a:lnL>
-                    <a:lnR w="6350" cap="flat" cmpd="sng" algn="ctr">
-                      <a:solidFill>
-                        <a:srgbClr val="D5DDE0"/>
-                      </a:solidFill>
-                      <a:prstDash val="solid"/>
-                      <a:round/>
-                      <a:headEnd type="none" w="med" len="med"/>
-                      <a:tailEnd type="none" w="med" len="med"/>
-                    </a:lnR>
-                    <a:lnT w="6350" cap="flat" cmpd="sng" algn="ctr">
-                      <a:solidFill>
-                        <a:srgbClr val="D5DDE0"/>
-                      </a:solidFill>
-                      <a:prstDash val="solid"/>
-                      <a:round/>
-                      <a:headEnd type="none" w="med" len="med"/>
-                      <a:tailEnd type="none" w="med" len="med"/>
-                    </a:lnT>
-                    <a:lnB w="6350" cap="flat" cmpd="sng" algn="ctr">
-                      <a:solidFill>
-                        <a:srgbClr val="D5DDE0"/>
-                      </a:solidFill>
-                      <a:prstDash val="solid"/>
-                      <a:round/>
-                      <a:headEnd type="none" w="med" len="med"/>
-                      <a:tailEnd type="none" w="med" len="med"/>
-                    </a:lnB>
-                    <a:solidFill>
-                      <a:srgbClr val="FFFFFF"/>
-                    </a:solidFill>
-                  </a:tcPr>
-                </a:tc>
-              </a:tr>
-              <a:tr h="384048">
-                <a:tc>
-                  <a:txBody>
-                    <a:bodyPr/>
-                    <a:lstStyle/>
-                    <a:p>
-                      <a:pPr indent="0" marL="0">
-                        <a:buNone/>
-                      </a:pPr>
-                      <a:r>
-                        <a:rPr lang="en-US" sz="1300" dirty="0">
-                          <a:solidFill>
-                            <a:schemeClr val="tx1"/>
-                          </a:solidFill>
-                        </a:rPr>
-                        <a:t>Revenue ($ millions)</a:t>
-                      </a:r>
-                      <a:endParaRPr lang="en-US" sz="1300" dirty="0"/>
-                    </a:p>
-                  </a:txBody>
-                  <a:tcPr marL="91440" marR="91440" marT="45720" marB="45720" anchor="ctr">
-                    <a:lnL w="6350" cap="flat" cmpd="sng" algn="ctr">
-                      <a:solidFill>
-                        <a:srgbClr val="D5DDE0"/>
-                      </a:solidFill>
-                      <a:prstDash val="solid"/>
-                      <a:round/>
-                      <a:headEnd type="none" w="med" len="med"/>
-                      <a:tailEnd type="none" w="med" len="med"/>
-                    </a:lnL>
-                    <a:lnR w="6350" cap="flat" cmpd="sng" algn="ctr">
-                      <a:solidFill>
-                        <a:srgbClr val="D5DDE0"/>
-                      </a:solidFill>
-                      <a:prstDash val="solid"/>
-                      <a:round/>
-                      <a:headEnd type="none" w="med" len="med"/>
-                      <a:tailEnd type="none" w="med" len="med"/>
-                    </a:lnR>
-                    <a:lnT w="6350" cap="flat" cmpd="sng" algn="ctr">
-                      <a:solidFill>
-                        <a:srgbClr val="D5DDE0"/>
-                      </a:solidFill>
-                      <a:prstDash val="solid"/>
-                      <a:round/>
-                      <a:headEnd type="none" w="med" len="med"/>
-                      <a:tailEnd type="none" w="med" len="med"/>
-                    </a:lnT>
-                    <a:lnB w="6350" cap="flat" cmpd="sng" algn="ctr">
-                      <a:solidFill>
-                        <a:srgbClr val="D5DDE0"/>
-                      </a:solidFill>
-                      <a:prstDash val="solid"/>
-                      <a:round/>
-                      <a:headEnd type="none" w="med" len="med"/>
-                      <a:tailEnd type="none" w="med" len="med"/>
-                    </a:lnB>
-                    <a:solidFill>
-                      <a:srgbClr val="FFFFFF"/>
-                    </a:solidFill>
-                  </a:tcPr>
-                </a:tc>
-                <a:tc>
-                  <a:txBody>
-                    <a:bodyPr/>
-                    <a:lstStyle/>
-                    <a:p>
-                      <a:pPr algn="r" indent="0" marL="0">
-                        <a:buNone/>
-                      </a:pPr>
-                      <a:r>
-                        <a:rPr lang="en-US" sz="1300" dirty="0">
-                          <a:solidFill>
-                            <a:schemeClr val="tx1"/>
-                          </a:solidFill>
-                        </a:rPr>
-                        <a:t>100</a:t>
-                      </a:r>
-                      <a:endParaRPr lang="en-US" sz="1300" dirty="0"/>
-                    </a:p>
-                  </a:txBody>
-                  <a:tcPr marL="91440" marR="91440" marT="45720" marB="45720" anchor="ctr">
-                    <a:lnL w="6350" cap="flat" cmpd="sng" algn="ctr">
-                      <a:solidFill>
-                        <a:srgbClr val="D5DDE0"/>
-                      </a:solidFill>
-                      <a:prstDash val="solid"/>
-                      <a:round/>
-                      <a:headEnd type="none" w="med" len="med"/>
-                      <a:tailEnd type="none" w="med" len="med"/>
-                    </a:lnL>
-                    <a:lnR w="6350" cap="flat" cmpd="sng" algn="ctr">
-                      <a:solidFill>
-                        <a:srgbClr val="D5DDE0"/>
-                      </a:solidFill>
-                      <a:prstDash val="solid"/>
-                      <a:round/>
-                      <a:headEnd type="none" w="med" len="med"/>
-                      <a:tailEnd type="none" w="med" len="med"/>
-                    </a:lnR>
-                    <a:lnT w="6350" cap="flat" cmpd="sng" algn="ctr">
-                      <a:solidFill>
-                        <a:srgbClr val="D5DDE0"/>
-                      </a:solidFill>
-                      <a:prstDash val="solid"/>
-                      <a:round/>
-                      <a:headEnd type="none" w="med" len="med"/>
-                      <a:tailEnd type="none" w="med" len="med"/>
-                    </a:lnT>
-                    <a:lnB w="6350" cap="flat" cmpd="sng" algn="ctr">
-                      <a:solidFill>
-                        <a:srgbClr val="D5DDE0"/>
-                      </a:solidFill>
-                      <a:prstDash val="solid"/>
-                      <a:round/>
-                      <a:headEnd type="none" w="med" len="med"/>
-                      <a:tailEnd type="none" w="med" len="med"/>
-                    </a:lnB>
-                    <a:solidFill>
-                      <a:srgbClr val="FFFFFF"/>
-                    </a:solidFill>
-                  </a:tcPr>
-                </a:tc>
-                <a:tc>
-                  <a:txBody>
-                    <a:bodyPr/>
-                    <a:lstStyle/>
-                    <a:p>
-                      <a:pPr algn="r" indent="0" marL="0">
-                        <a:buNone/>
-                      </a:pPr>
-                      <a:r>
-                        <a:rPr lang="en-US" sz="1300" dirty="0">
-                          <a:solidFill>
-                            <a:schemeClr val="tx1"/>
-                          </a:solidFill>
-                        </a:rPr>
-                        <a:t>317</a:t>
-                      </a:r>
-                      <a:endParaRPr lang="en-US" sz="1300" dirty="0"/>
-                    </a:p>
-                  </a:txBody>
-                  <a:tcPr marL="91440" marR="91440" marT="45720" marB="45720" anchor="ctr">
-                    <a:lnL w="6350" cap="flat" cmpd="sng" algn="ctr">
-                      <a:solidFill>
-                        <a:srgbClr val="D5DDE0"/>
-                      </a:solidFill>
-                      <a:prstDash val="solid"/>
-                      <a:round/>
-                      <a:headEnd type="none" w="med" len="med"/>
-                      <a:tailEnd type="none" w="med" len="med"/>
-                    </a:lnL>
-                    <a:lnR w="6350" cap="flat" cmpd="sng" algn="ctr">
-                      <a:solidFill>
-                        <a:srgbClr val="D5DDE0"/>
-                      </a:solidFill>
-                      <a:prstDash val="solid"/>
-                      <a:round/>
-                      <a:headEnd type="none" w="med" len="med"/>
-                      <a:tailEnd type="none" w="med" len="med"/>
-                    </a:lnR>
-                    <a:lnT w="6350" cap="flat" cmpd="sng" algn="ctr">
-                      <a:solidFill>
-                        <a:srgbClr val="D5DDE0"/>
-                      </a:solidFill>
-                      <a:prstDash val="solid"/>
-                      <a:round/>
-                      <a:headEnd type="none" w="med" len="med"/>
-                      <a:tailEnd type="none" w="med" len="med"/>
-                    </a:lnT>
-                    <a:lnB w="6350" cap="flat" cmpd="sng" algn="ctr">
-                      <a:solidFill>
-                        <a:srgbClr val="D5DDE0"/>
-                      </a:solidFill>
-                      <a:prstDash val="solid"/>
-                      <a:round/>
-                      <a:headEnd type="none" w="med" len="med"/>
-                      <a:tailEnd type="none" w="med" len="med"/>
-                    </a:lnB>
-                    <a:solidFill>
-                      <a:srgbClr val="FFFFFF"/>
-                    </a:solidFill>
-                  </a:tcPr>
-                </a:tc>
-                <a:tc>
-                  <a:txBody>
-                    <a:bodyPr/>
-                    <a:lstStyle/>
-                    <a:p>
-                      <a:pPr algn="r" indent="0" marL="0">
-                        <a:buNone/>
-                      </a:pPr>
-                      <a:r>
-                        <a:rPr lang="en-US" sz="1300" dirty="0">
-                          <a:solidFill>
-                            <a:schemeClr val="tx1"/>
-                          </a:solidFill>
-                        </a:rPr>
-                        <a:t>2,469</a:t>
-                      </a:r>
-                      <a:endParaRPr lang="en-US" sz="1300" dirty="0"/>
-                    </a:p>
-                  </a:txBody>
-                  <a:tcPr marL="91440" marR="91440" marT="45720" marB="45720" anchor="ctr">
-                    <a:lnL w="6350" cap="flat" cmpd="sng" algn="ctr">
-                      <a:solidFill>
-                        <a:srgbClr val="D5DDE0"/>
-                      </a:solidFill>
-                      <a:prstDash val="solid"/>
-                      <a:round/>
-                      <a:headEnd type="none" w="med" len="med"/>
-                      <a:tailEnd type="none" w="med" len="med"/>
-                    </a:lnL>
-                    <a:lnR w="6350" cap="flat" cmpd="sng" algn="ctr">
-                      <a:solidFill>
-                        <a:srgbClr val="D5DDE0"/>
-                      </a:solidFill>
-                      <a:prstDash val="solid"/>
-                      <a:round/>
-                      <a:headEnd type="none" w="med" len="med"/>
-                      <a:tailEnd type="none" w="med" len="med"/>
-                    </a:lnR>
-                    <a:lnT w="6350" cap="flat" cmpd="sng" algn="ctr">
-                      <a:solidFill>
-                        <a:srgbClr val="D5DDE0"/>
-                      </a:solidFill>
-                      <a:prstDash val="solid"/>
-                      <a:round/>
-                      <a:headEnd type="none" w="med" len="med"/>
-                      <a:tailEnd type="none" w="med" len="med"/>
-                    </a:lnT>
-                    <a:lnB w="6350" cap="flat" cmpd="sng" algn="ctr">
-                      <a:solidFill>
-                        <a:srgbClr val="D5DDE0"/>
-                      </a:solidFill>
-                      <a:prstDash val="solid"/>
-                      <a:round/>
-                      <a:headEnd type="none" w="med" len="med"/>
-                      <a:tailEnd type="none" w="med" len="med"/>
-                    </a:lnB>
-                    <a:solidFill>
-                      <a:srgbClr val="FFFFFF"/>
-                    </a:solidFill>
-                  </a:tcPr>
-                </a:tc>
-                <a:tc>
-                  <a:txBody>
-                    <a:bodyPr/>
-                    <a:lstStyle/>
-                    <a:p>
-                      <a:pPr algn="r" indent="0" marL="0">
-                        <a:buNone/>
-                      </a:pPr>
-                      <a:r>
-                        <a:rPr lang="en-US" sz="1300" dirty="0">
-                          <a:solidFill>
-                            <a:schemeClr val="tx1"/>
-                          </a:solidFill>
-                        </a:rPr>
-                        <a:t>58,054</a:t>
-                      </a:r>
-                      <a:endParaRPr lang="en-US" sz="1300" dirty="0"/>
-                    </a:p>
-                  </a:txBody>
-                  <a:tcPr marL="91440" marR="91440" marT="45720" marB="45720" anchor="ctr">
-                    <a:lnL w="6350" cap="flat" cmpd="sng" algn="ctr">
-                      <a:solidFill>
-                        <a:srgbClr val="D5DDE0"/>
-                      </a:solidFill>
-                      <a:prstDash val="solid"/>
-                      <a:round/>
-                      <a:headEnd type="none" w="med" len="med"/>
-                      <a:tailEnd type="none" w="med" len="med"/>
-                    </a:lnL>
-                    <a:lnR w="6350" cap="flat" cmpd="sng" algn="ctr">
-                      <a:solidFill>
-                        <a:srgbClr val="D5DDE0"/>
-                      </a:solidFill>
-                      <a:prstDash val="solid"/>
-                      <a:round/>
-                      <a:headEnd type="none" w="med" len="med"/>
-                      <a:tailEnd type="none" w="med" len="med"/>
-                    </a:lnR>
-                    <a:lnT w="6350" cap="flat" cmpd="sng" algn="ctr">
-                      <a:solidFill>
-                        <a:srgbClr val="D5DDE0"/>
-                      </a:solidFill>
-                      <a:prstDash val="solid"/>
-                      <a:round/>
-                      <a:headEnd type="none" w="med" len="med"/>
-                      <a:tailEnd type="none" w="med" len="med"/>
-                    </a:lnT>
-                    <a:lnB w="6350" cap="flat" cmpd="sng" algn="ctr">
-                      <a:solidFill>
-                        <a:srgbClr val="D5DDE0"/>
-                      </a:solidFill>
-                      <a:prstDash val="solid"/>
-                      <a:round/>
-                      <a:headEnd type="none" w="med" len="med"/>
-                      <a:tailEnd type="none" w="med" len="med"/>
-                    </a:lnB>
-                    <a:solidFill>
-                      <a:srgbClr val="FFFFFF"/>
-                    </a:solidFill>
-                  </a:tcPr>
-                </a:tc>
-              </a:tr>
-            </a:tbl>
-          </a:graphicData>
-        </a:graphic>
-      </p:graphicFrame>
-      <p:sp>
-        <p:nvSpPr>
-          <p:cNvPr id="4" name="Text 1"/>
-          <p:cNvSpPr txBox="1"/>
-          <p:nvPr/>
-        </p:nvSpPr>
-        <p:spPr>
-          <a:xfrm>
-            <a:off x="548640" y="3154680"/>
-            <a:ext cx="6583680" cy="640080"/>
-          </a:xfrm>
-          <a:prstGeom prst="rect">
-            <a:avLst/>
-          </a:prstGeom>
-          <a:noFill/>
-          <a:ln/>
-        </p:spPr>
-        <p:txBody>
-          <a:bodyPr wrap="square" lIns="0" tIns="0" rIns="0" bIns="0" rtlCol="0" anchor="t"/>
-          <a:lstStyle/>
-          <a:p>
-            <a:pPr indent="0" marL="0">
-              <a:buNone/>
-            </a:pPr>
-            <a:r>
-              <a:rPr lang="en-US" sz="1300" dirty="0">
-                <a:solidFill>
-                  <a:schemeClr val="tx1"/>
-                </a:solidFill>
-              </a:rPr>
-              <a:t>n = 833 company-years (201 firms). MVE is strongly right-skewed (mean about 5× the median), which is why the charts use a log axis.</a:t>
-            </a:r>
-            <a:endParaRPr lang="en-US" sz="1300" dirty="0"/>
-          </a:p>
-        </p:txBody>
-      </p:sp>
-      <p:sp>
-        <p:nvSpPr>
-          <p:cNvPr id="5" name="Text 2"/>
-          <p:cNvSpPr txBox="1"/>
-          <p:nvPr/>
-        </p:nvSpPr>
-        <p:spPr>
-          <a:xfrm>
-            <a:off x="7498080" y="1371600"/>
-            <a:ext cx="4142232" cy="320040"/>
-          </a:xfrm>
-          <a:prstGeom prst="rect">
-            <a:avLst/>
-          </a:prstGeom>
-          <a:noFill/>
-          <a:ln/>
-        </p:spPr>
-        <p:txBody>
-          <a:bodyPr wrap="square" lIns="0" tIns="0" rIns="0" bIns="0" rtlCol="0" anchor="ctr"/>
-          <a:lstStyle/>
-          <a:p>
-            <a:pPr indent="0" marL="0">
-              <a:buNone/>
-            </a:pPr>
-            <a:r>
-              <a:rPr lang="en-US" sz="1600" b="1" dirty="0">
-                <a:solidFill>
-                  <a:schemeClr val="tx2"/>
-                </a:solidFill>
-              </a:rPr>
-              <a:t>Method notes</a:t>
-            </a:r>
-            <a:endParaRPr lang="en-US" sz="1600" dirty="0"/>
-          </a:p>
-        </p:txBody>
-      </p:sp>
-      <p:sp>
-        <p:nvSpPr>
-          <p:cNvPr id="6" name="Text 3"/>
-          <p:cNvSpPr txBox="1"/>
-          <p:nvPr/>
-        </p:nvSpPr>
-        <p:spPr>
-          <a:xfrm>
-            <a:off x="7498080" y="1737360"/>
-            <a:ext cx="4142232" cy="4480560"/>
-          </a:xfrm>
-          <a:prstGeom prst="rect">
-            <a:avLst/>
-          </a:prstGeom>
-          <a:noFill/>
-          <a:ln/>
-        </p:spPr>
-        <p:txBody>
-          <a:bodyPr wrap="square" lIns="0" tIns="0" rIns="0" bIns="0" rtlCol="0" anchor="t"/>
-          <a:lstStyle/>
-          <a:p>
-            <a:pPr marL="203200" indent="-203200">
-              <a:spcAft>
-                <a:spcPts val="600"/>
-              </a:spcAft>
-              <a:buSzPct val="100000"/>
-              <a:buChar char="•"/>
-            </a:pPr>
-            <a:r>
-              <a:rPr lang="en-US" sz="1400" dirty="0">
-                <a:solidFill>
-                  <a:schemeClr val="tx1"/>
-                </a:solidFill>
-              </a:rPr>
-              <a:t>Trend line: LOESS of log(MVE) on age, span 0.4, drawn over the 1st–99th percentile of age</a:t>
-            </a:r>
-            <a:endParaRPr lang="en-US" sz="1400" dirty="0"/>
-          </a:p>
-          <a:p>
-            <a:pPr marL="203200" indent="-203200">
-              <a:spcAft>
-                <a:spcPts val="600"/>
-              </a:spcAft>
-              <a:buSzPct val="100000"/>
-              <a:buChar char="•"/>
-            </a:pPr>
-            <a:r>
-              <a:rPr lang="en-US" sz="1400" dirty="0">
-                <a:solidFill>
-                  <a:schemeClr val="tx1"/>
-                </a:solidFill>
-              </a:rPr>
-              <a:t>95% band: 300 resamples of whole firms, refitting each time</a:t>
-            </a:r>
-            <a:endParaRPr lang="en-US" sz="1400" dirty="0"/>
-          </a:p>
-          <a:p>
-            <a:pPr marL="203200" indent="-203200">
-              <a:spcAft>
-                <a:spcPts val="600"/>
-              </a:spcAft>
-              <a:buSzPct val="100000"/>
-              <a:buChar char="•"/>
-            </a:pPr>
-            <a:r>
-              <a:rPr lang="en-US" sz="1400" dirty="0">
-                <a:solidFill>
-                  <a:schemeClr val="tx1"/>
-                </a:solidFill>
-              </a:rPr>
-              <a:t>Axes: MVE log scale; R&amp;D / revenue linear; debt / equity symmetric-log (it has negative values)</a:t>
-            </a:r>
-            <a:endParaRPr lang="en-US" sz="1400" dirty="0"/>
-          </a:p>
-          <a:p>
-            <a:pPr marL="203200" indent="-203200">
-              <a:spcAft>
-                <a:spcPts val="600"/>
-              </a:spcAft>
-              <a:buSzPct val="100000"/>
-              <a:buChar char="•"/>
-            </a:pPr>
-            <a:r>
-              <a:rPr lang="en-US" sz="1400" dirty="0">
-                <a:solidFill>
-                  <a:schemeClr val="tx1"/>
-                </a:solidFill>
-              </a:rPr>
-              <a:t>Reproduce: see the README in the repository (Python scripts for the charts and this deck)</a:t>
             </a:r>
             <a:endParaRPr lang="en-US" sz="1400" dirty="0"/>
           </a:p>

</xml_diff>

<commit_message>
Add footer and GitHub/source-file references to deck
Co-Authored-By: Claude Sonnet 5.5 <noreply@anthropic.com>
Claude-Session: https://claude.ai/code/session_017of5yU3bfrpCMXsVcsfLUs
</commit_message>
<xml_diff>
--- a/out/Biotech_MVE_vs_Age.pptx
+++ b/out/Biotech_MVE_vs_Age.pptx
@@ -116,7 +116,7 @@
   <p:extLst>
     <p:ext uri="{521415D9-36F7-43E2-AB2F-B90AF26B5E84}">
       <p14:sectionLst xmlns:p14="http://schemas.microsoft.com/office/powerpoint/2010/main">
-        <p14:section name="Main" id="{e20b97fe-dd95-b591-3914-3596a240ca30}">
+        <p14:section name="Main" id="{b0877032-617a-91a2-7746-9d3f0b40b666}">
           <p14:sldIdLst>
             <p14:sldId id="256"/>
             <p14:sldId id="257"/>
@@ -126,7 +126,7 @@
             <p14:sldId id="261"/>
           </p14:sldIdLst>
         </p14:section>
-        <p14:section name="Appendix" id="{e395e33f-dc30-46e0-37ed-2147049329c9}">
+        <p14:section name="Appendix" id="{22e5469d-548e-be3a-3658-da3279d08783}">
           <p14:sldIdLst>
             <p14:sldId id="262"/>
             <p14:sldId id="263"/>
@@ -1877,6 +1877,42 @@
           </a:p>
         </p:txBody>
       </p:sp>
+      <p:sp>
+        <p:nvSpPr>
+          <p:cNvPr id="4" name="Text 0"/>
+          <p:cNvSpPr/>
+          <p:nvPr/>
+        </p:nvSpPr>
+        <p:spPr>
+          <a:xfrm>
+            <a:off x="548640" y="6446520"/>
+            <a:ext cx="7315200" cy="274320"/>
+          </a:xfrm>
+          <a:prstGeom prst="rect">
+            <a:avLst/>
+          </a:prstGeom>
+          <a:noFill/>
+          <a:ln/>
+        </p:spPr>
+        <p:txBody>
+          <a:bodyPr wrap="square" lIns="0" tIns="0" rIns="0" bIns="0" rtlCol="0" anchor="ctr"/>
+          <a:lstStyle/>
+          <a:p>
+            <a:pPr indent="0" marL="0">
+              <a:buNone/>
+            </a:pPr>
+            <a:r>
+              <a:rPr lang="en-US" sz="1000" dirty="0">
+                <a:solidFill>
+                  <a:schemeClr val="bg2"/>
+                </a:solidFill>
+              </a:rPr>
+              <a:t>Created with Claude - Reviewed by Jacob Willson</a:t>
+            </a:r>
+            <a:endParaRPr lang="en-US" sz="1000" dirty="0"/>
+          </a:p>
+        </p:txBody>
+      </p:sp>
     </p:spTree>
   </p:cSld>
   <p:clrMapOvr>
@@ -1960,7 +1996,7 @@
         <p:spPr>
           <a:xfrm>
             <a:off x="548640" y="6446520"/>
-            <a:ext cx="5486400" cy="274320"/>
+            <a:ext cx="7315200" cy="274320"/>
           </a:xfrm>
           <a:prstGeom prst="rect">
             <a:avLst/>
@@ -1981,7 +2017,7 @@
                   <a:schemeClr val="accent3"/>
                 </a:solidFill>
               </a:rPr>
-              <a:t>Biotech Industry - MVE vs Age</a:t>
+              <a:t>Created with Claude - Reviewed by Jacob Willson</a:t>
             </a:r>
             <a:endParaRPr lang="en-US" sz="1000" dirty="0"/>
           </a:p>
@@ -4194,7 +4230,7 @@
                   <a:schemeClr val="tx1"/>
                 </a:solidFill>
               </a:rPr>
-              <a:t>Reproduce: see the README in the repository (Python scripts for the charts and this deck)</a:t>
+              <a:t>Reproduce: Python and Node scripts, data extract and README at github.com/AlwaysOverachieve/Project1</a:t>
             </a:r>
             <a:endParaRPr lang="en-US" sz="1400" dirty="0"/>
           </a:p>
@@ -7639,7 +7675,7 @@
                   <a:schemeClr val="tx1"/>
                 </a:solidFill>
               </a:rPr>
-              <a:t>lines of data, all available columns</a:t>
+              <a:t>lines of data, all available columns (CompustatData.xlsx)</a:t>
             </a:r>
             <a:endParaRPr lang="en-US" sz="1400" dirty="0"/>
           </a:p>
@@ -8017,7 +8053,7 @@
         <p:spPr>
           <a:xfrm>
             <a:off x="548640" y="3931920"/>
-            <a:ext cx="11091672" cy="2377440"/>
+            <a:ext cx="11091672" cy="1783080"/>
           </a:xfrm>
           <a:prstGeom prst="rect">
             <a:avLst/>
@@ -8099,6 +8135,82 @@
               <a:t>To test them, rebuild the charts from the full table with and without each filter</a:t>
             </a:r>
             <a:endParaRPr lang="en-US" sz="1500" dirty="0"/>
+          </a:p>
+        </p:txBody>
+      </p:sp>
+      <p:sp>
+        <p:nvSpPr>
+          <p:cNvPr id="18" name="Repository link"/>
+          <p:cNvSpPr txBox="1"/>
+          <p:nvPr/>
+        </p:nvSpPr>
+        <p:spPr>
+          <a:xfrm>
+            <a:off x="548640" y="5852160"/>
+            <a:ext cx="11091672" cy="457200"/>
+          </a:xfrm>
+          <a:prstGeom prst="rect">
+            <a:avLst/>
+          </a:prstGeom>
+          <a:noFill/>
+          <a:ln/>
+        </p:spPr>
+        <p:txBody>
+          <a:bodyPr wrap="square" lIns="0" tIns="0" rIns="0" bIns="0" rtlCol="0" anchor="ctr"/>
+          <a:lstStyle/>
+          <a:p>
+            <a:pPr indent="0" marL="0">
+              <a:buNone/>
+            </a:pPr>
+            <a:r>
+              <a:rPr lang="en-US" sz="1400" b="1" dirty="0">
+                <a:solidFill>
+                  <a:schemeClr val="tx2"/>
+                </a:solidFill>
+              </a:rPr>
+              <a:t>Code, data extract and README: </a:t>
+            </a:r>
+            <a:pPr indent="0" marL="0">
+              <a:buNone/>
+            </a:pPr>
+            <a:r>
+              <a:rPr lang="en-US" sz="1400" u="sng" dirty="0">
+                <a:solidFill>
+                  <a:schemeClr val="accent1"/>
+                </a:solidFill>
+                <a:hlinkClick r:id="rId1" invalidUrl="" action="" tgtFrame="" tooltip="Project repository on GitHub" history="1" highlightClick="0" endSnd="0">
+                  <a:extLst>
+                    <a:ext uri="{A12FA001-AC4F-418D-AE19-62706E023703}">
+                      <ahyp:hlinkClr xmlns:ahyp="http://schemas.microsoft.com/office/drawing/2018/hyperlinkcolor" val="tx"/>
+                    </a:ext>
+                  </a:extLst>
+                </a:hlinkClick>
+              </a:rPr>
+              <a:t>https://github.com/AlwaysOverachieve/Project1</a:t>
+            </a:r>
+            <a:pPr indent="0" marL="0">
+              <a:buNone/>
+            </a:pPr>
+            <a:r>
+              <a:rPr lang="en-US" sz="1400" b="1" dirty="0">
+                <a:solidFill>
+                  <a:schemeClr val="tx2"/>
+                </a:solidFill>
+              </a:rPr>
+              <a:t>   |   Full source table: </a:t>
+            </a:r>
+            <a:pPr indent="0" marL="0">
+              <a:buNone/>
+            </a:pPr>
+            <a:r>
+              <a:rPr lang="en-US" sz="1400" dirty="0">
+                <a:solidFill>
+                  <a:schemeClr val="tx1"/>
+                </a:solidFill>
+              </a:rPr>
+              <a:t>CompustatData.xlsx (in the repository)</a:t>
+            </a:r>
+            <a:endParaRPr lang="en-US" sz="1400" dirty="0"/>
           </a:p>
         </p:txBody>
       </p:sp>

</xml_diff>

<commit_message>
Replace source-file reference with request-a-copy note; update README
Co-Authored-By: Claude Sonnet 5.5 <noreply@anthropic.com>
Claude-Session: https://claude.ai/code/session_017of5yU3bfrpCMXsVcsfLUs
</commit_message>
<xml_diff>
--- a/out/Biotech_MVE_vs_Age.pptx
+++ b/out/Biotech_MVE_vs_Age.pptx
@@ -116,7 +116,7 @@
   <p:extLst>
     <p:ext uri="{521415D9-36F7-43E2-AB2F-B90AF26B5E84}">
       <p14:sectionLst xmlns:p14="http://schemas.microsoft.com/office/powerpoint/2010/main">
-        <p14:section name="Main" id="{b0877032-617a-91a2-7746-9d3f0b40b666}">
+        <p14:section name="Main" id="{8357c4bb-6f98-d636-f299-696db1225168}">
           <p14:sldIdLst>
             <p14:sldId id="256"/>
             <p14:sldId id="257"/>
@@ -126,7 +126,7 @@
             <p14:sldId id="261"/>
           </p14:sldIdLst>
         </p14:section>
-        <p14:section name="Appendix" id="{22e5469d-548e-be3a-3658-da3279d08783}">
+        <p14:section name="Appendix" id="{4a4d491f-f816-6165-4494-896573503181}">
           <p14:sldIdLst>
             <p14:sldId id="262"/>
             <p14:sldId id="263"/>
@@ -7675,7 +7675,7 @@
                   <a:schemeClr val="tx1"/>
                 </a:solidFill>
               </a:rPr>
-              <a:t>lines of data, all available columns (CompustatData.xlsx)</a:t>
+              <a:t>lines of data, all available columns</a:t>
             </a:r>
             <a:endParaRPr lang="en-US" sz="1400" dirty="0"/>
           </a:p>
@@ -8197,7 +8197,7 @@
                   <a:schemeClr val="tx2"/>
                 </a:solidFill>
               </a:rPr>
-              <a:t>   |   Full source table: </a:t>
+              <a:t>   |   Original source file: </a:t>
             </a:r>
             <a:pPr indent="0" marL="0">
               <a:buNone/>
@@ -8208,7 +8208,7 @@
                   <a:schemeClr val="tx1"/>
                 </a:solidFill>
               </a:rPr>
-              <a:t>CompustatData.xlsx (in the repository)</a:t>
+              <a:t>too large to host; message Jacob Willson for a copy</a:t>
             </a:r>
             <a:endParaRPr lang="en-US" sz="1400" dirty="0"/>
           </a:p>

</xml_diff>

<commit_message>
Shorten repository link label on Appendix A1
Co-Authored-By: Claude Sonnet 5.5 <noreply@anthropic.com>
Claude-Session: https://claude.ai/code/session_017of5yU3bfrpCMXsVcsfLUs
</commit_message>
<xml_diff>
--- a/out/Biotech_MVE_vs_Age.pptx
+++ b/out/Biotech_MVE_vs_Age.pptx
@@ -116,7 +116,7 @@
   <p:extLst>
     <p:ext uri="{521415D9-36F7-43E2-AB2F-B90AF26B5E84}">
       <p14:sectionLst xmlns:p14="http://schemas.microsoft.com/office/powerpoint/2010/main">
-        <p14:section name="Main" id="{8357c4bb-6f98-d636-f299-696db1225168}">
+        <p14:section name="Main" id="{83d30d71-6f4a-08c0-430a-c1bc2d96d06b}">
           <p14:sldIdLst>
             <p14:sldId id="256"/>
             <p14:sldId id="257"/>
@@ -126,7 +126,7 @@
             <p14:sldId id="261"/>
           </p14:sldIdLst>
         </p14:section>
-        <p14:section name="Appendix" id="{4a4d491f-f816-6165-4494-896573503181}">
+        <p14:section name="Appendix" id="{ff777171-d0cf-732e-0211-d2e9f6de6549}">
           <p14:sldIdLst>
             <p14:sldId id="262"/>
             <p14:sldId id="263"/>
@@ -8168,7 +8168,7 @@
                   <a:schemeClr val="tx2"/>
                 </a:solidFill>
               </a:rPr>
-              <a:t>Code, data extract and README: </a:t>
+              <a:t>Code and data: </a:t>
             </a:r>
             <a:pPr indent="0" marL="0">
               <a:buNone/>

</xml_diff>